<commit_message>
Form 2: revise all 19 lessons to the validated model
Syllabus points in order with their headings, definitions in a separate
block, one element per slide with its picture, situations ending with the
character's question, one question per activity slide.

Co-Authored-By: Claude Opus 5.5 <noreply@anthropic.com>
Claude-Session: https://claude.ai/code/session_0115LFSb2ktGLWPeVksFkSer
</commit_message>
<xml_diff>
--- a/lecons/F2/01_F2_M1_L01_A_Rapid_Growth_of_the_World_s_Population.pptx
+++ b/lecons/F2/01_F2_M1_L01_A_Rapid_Growth_of_the_World_s_Population.pptx
@@ -56,9 +56,12 @@
     <p:sldId id="304" r:id="rId50"/>
     <p:sldId id="305" r:id="rId51"/>
     <p:sldId id="306" r:id="rId52"/>
+    <p:sldId id="307" r:id="rId53"/>
+    <p:sldId id="308" r:id="rId54"/>
+    <p:sldId id="309" r:id="rId55"/>
   </p:sldIdLst>
   <p:notesMasterIdLst>
-    <p:notesMasterId r:id="rId53"/>
+    <p:notesMasterId r:id="rId56"/>
   </p:notesMasterIdLst>
   <p:sldSz cx="12192000" cy="6858000"/>
   <p:notesSz cx="6858000" cy="12192000"/>
@@ -640,7 +643,7 @@
           <a:p>
             <a:r>
               <a:rPr lang="en-US" dirty="0"/>
-              <a:t>Good. The population of the village has grown quickly.</a:t>
+              <a:t>Good. The grandson does not know why the population has grown so fast and what it means for the land.</a:t>
             </a:r>
             <a:endParaRPr lang="en-US" dirty="0"/>
           </a:p>
@@ -992,7 +995,7 @@
           <a:p>
             <a:r>
               <a:rPr lang="en-US" dirty="0"/>
-              <a:t>Good. There are more people sharing the same land.</a:t>
+              <a:t>Good. More people share the same land.</a:t>
             </a:r>
             <a:endParaRPr lang="en-US" dirty="0"/>
           </a:p>
@@ -1344,7 +1347,7 @@
           <a:p>
             <a:r>
               <a:rPr lang="en-US" dirty="0"/>
-              <a:t>Here is the question for Activity 1: How many people lived on the Earth in 1800 and in 2022? Take one minute to think and write your answer in your rough notebook.</a:t>
+              <a:t>Here is the question for Activity 1: About how many people lived on the Earth in 1800? Take one minute to think and write your answer in your rough notebook.</a:t>
             </a:r>
             <a:endParaRPr lang="en-US" dirty="0"/>
           </a:p>
@@ -1432,7 +1435,7 @@
           <a:p>
             <a:r>
               <a:rPr lang="en-US" dirty="0"/>
-              <a:t>Let us check the answer together. About 1 billion in 1800 and 8 billion in 2022.</a:t>
+              <a:t>Let us check the answer together. About 1 billion.</a:t>
             </a:r>
             <a:endParaRPr lang="en-US" dirty="0"/>
           </a:p>
@@ -1608,7 +1611,7 @@
           <a:p>
             <a:r>
               <a:rPr lang="en-US" dirty="0"/>
-              <a:t>Activity 2. Look carefully at this picture: a crowded market. Observe every detail before I ask the question.</a:t>
+              <a:t>Activity 2. Look carefully at this diagram: world population over time. Observe every detail before I ask the question.</a:t>
             </a:r>
             <a:endParaRPr lang="en-US" dirty="0"/>
           </a:p>
@@ -1696,7 +1699,7 @@
           <a:p>
             <a:r>
               <a:rPr lang="en-US" dirty="0"/>
-              <a:t>Here is the question for Activity 2: Is the world population growing slowly or quickly today? Take one minute to think and write your answer in your rough notebook.</a:t>
+              <a:t>Here is the question for Activity 2: About how many people live on the Earth today? Take one minute to think and write your answer in your rough notebook.</a:t>
             </a:r>
             <a:endParaRPr lang="en-US" dirty="0"/>
           </a:p>
@@ -1784,7 +1787,7 @@
           <a:p>
             <a:r>
               <a:rPr lang="en-US" dirty="0"/>
-              <a:t>Let us check the answer together. Quickly: it has grown very fast since about 1950.</a:t>
+              <a:t>Let us check the answer together. More than 8 billion: the population has grown very fast since 1950.</a:t>
             </a:r>
             <a:endParaRPr lang="en-US" dirty="0"/>
           </a:p>
@@ -2136,7 +2139,7 @@
           <a:p>
             <a:r>
               <a:rPr lang="en-US" dirty="0"/>
-              <a:t>Activity 4. Look carefully at this diagram: birth rate and death rate. Observe every detail before I ask the question.</a:t>
+              <a:t>Activity 4. Look carefully at this diagram: births and deaths. Observe every detail before I ask the question.</a:t>
             </a:r>
             <a:endParaRPr lang="en-US" dirty="0"/>
           </a:p>
@@ -2312,7 +2315,7 @@
           <a:p>
             <a:r>
               <a:rPr lang="en-US" dirty="0"/>
-              <a:t>Let us check the answer together. The population grows (natural increase).</a:t>
+              <a:t>Let us check the answer together. The population grows: this is natural growth.</a:t>
             </a:r>
             <a:endParaRPr lang="en-US" dirty="0"/>
           </a:p>
@@ -2488,7 +2491,7 @@
           <a:p>
             <a:r>
               <a:rPr lang="en-US" dirty="0"/>
-              <a:t>Our topic is Man in his Environment, and the sub-topic is The World's Population. The key notions we shall use today are: population, natural population growth, birth rate, death rate, resources. At the end, you should be able to do this: learners are able to describe the growth of the world population and its effects on natural resources.</a:t>
+              <a:t>Our topic is Man in his Environment, and the sub-topic is The World's Population. The key notions we shall use today are: population, natural population growth, resources. At the end, you should be able to do this: learners are able to describe the growth of the world population and its effects on natural resources.</a:t>
             </a:r>
             <a:endParaRPr lang="en-US" dirty="0"/>
           </a:p>
@@ -2576,7 +2579,7 @@
           <a:p>
             <a:r>
               <a:rPr lang="en-US" dirty="0"/>
-              <a:t>Here is the question for Activity 5: Give two effects of rapid population growth on natural resources. Take one minute to think and write your answer in your rough notebook.</a:t>
+              <a:t>Here is the question for Activity 5: Why is the forest cut when the population grows? Take one minute to think and write your answer in your rough notebook.</a:t>
             </a:r>
             <a:endParaRPr lang="en-US" dirty="0"/>
           </a:p>
@@ -2664,7 +2667,7 @@
           <a:p>
             <a:r>
               <a:rPr lang="en-US" dirty="0"/>
-              <a:t>Let us check the answer together. Forests are cut for farms and firewood; land and water become scarce.</a:t>
+              <a:t>Let us check the answer together. More people need more land for farms and more wood for fuel and houses.</a:t>
             </a:r>
             <a:endParaRPr lang="en-US" dirty="0"/>
           </a:p>
@@ -2840,7 +2843,7 @@
           <a:p>
             <a:r>
               <a:rPr lang="en-US" dirty="0"/>
-              <a:t>Let us copy the definitions. The key terms of this lesson are defined as follows. On this slide we have Population and Natural growth. Write each point on a new line, with the key term first, and explain it in your own words when we revise.</a:t>
+              <a:t>Let us copy the definitions. The key terms of this lesson are defined as follows. On this slide we have Population and Natural population growth. Write each point on a new line, with the key term first, and explain it in your own words when we revise. When you finish, we go to the next slide.</a:t>
             </a:r>
             <a:endParaRPr lang="en-US" dirty="0"/>
           </a:p>
@@ -2928,7 +2931,7 @@
           <a:p>
             <a:r>
               <a:rPr lang="en-US" dirty="0"/>
-              <a:t>Let us copy Evolution of the World's Population. The world population has grown as follows. On this slide we have Slow growth and Rapid growth. Write each point on a new line, with the key term first, and explain it in your own words when we revise.</a:t>
+              <a:t>We continue with the definitions. On this slide we have Resources. Write each point on a new line, with the key term first, and explain it in your own words when we revise.</a:t>
             </a:r>
             <a:endParaRPr lang="en-US" dirty="0"/>
           </a:p>
@@ -3016,7 +3019,7 @@
           <a:p>
             <a:r>
               <a:rPr lang="en-US" dirty="0"/>
-              <a:t>Now draw this illustration in your notebook: world population growth. Give it a title and label it clearly.</a:t>
+              <a:t>Let us copy Evolution of the World's Population. The world population has evolved as follows. On this slide we have Slow growth and Faster growth. Write each point on a new line, with the key term first, and explain it in your own words when we revise.</a:t>
             </a:r>
             <a:endParaRPr lang="en-US" dirty="0"/>
           </a:p>
@@ -3104,7 +3107,7 @@
           <a:p>
             <a:r>
               <a:rPr lang="en-US" dirty="0"/>
-              <a:t>Let us copy Factors of Population Growth. The population grows for the following reasons. On this slide we have High birth rate and Falling death rate. Write each point on a new line, with the key term first, and explain it in your own words when we revise. When you finish, we go to the next slide.</a:t>
+              <a:t>Copy the point on Rapid growth on the left, then draw the diagram on the right: world population growth. Give it a title and label it clearly.</a:t>
             </a:r>
             <a:endParaRPr lang="en-US" dirty="0"/>
           </a:p>
@@ -3192,7 +3195,7 @@
           <a:p>
             <a:r>
               <a:rPr lang="en-US" dirty="0"/>
-              <a:t>We continue with Factors of Population Growth. On this slide we have Better food supply. Write each point on a new line, with the key term first, and explain it in your own words when we revise.</a:t>
+              <a:t>Let us copy Factors of the Population Growth. The population grows for the following reasons. Copy the point on High birth rate on the left, then draw the diagram on the right: children. Give it a title and label it clearly.</a:t>
             </a:r>
             <a:endParaRPr lang="en-US" dirty="0"/>
           </a:p>
@@ -3280,7 +3283,7 @@
           <a:p>
             <a:r>
               <a:rPr lang="en-US" dirty="0"/>
-              <a:t>Let us copy Implications on Natural Resources. Rapid growth has the following effects on resources. On this slide we have Land and Forests. Write each point on a new line, with the key term first, and explain it in your own words when we revise. When you finish, we go to the next slide.</a:t>
+              <a:t>Copy the point on Falling death rate on the left, then draw the diagram on the right: a vaccination. Give it a title and label it clearly.</a:t>
             </a:r>
             <a:endParaRPr lang="en-US" dirty="0"/>
           </a:p>
@@ -3368,7 +3371,7 @@
           <a:p>
             <a:r>
               <a:rPr lang="en-US" dirty="0"/>
-              <a:t>We continue with Implications on Natural Resources. On this slide we have Water. Write each point on a new line, with the key term first, and explain it in your own words when we revise.</a:t>
+              <a:t>We continue with Factors of the Population Growth. On this slide we have Better food supply and Early marriages and big families. Write each point on a new line, with the key term first, and explain it in your own words when we revise.</a:t>
             </a:r>
             <a:endParaRPr lang="en-US" dirty="0"/>
           </a:p>
@@ -3544,7 +3547,7 @@
           <a:p>
             <a:r>
               <a:rPr lang="en-US" dirty="0"/>
-              <a:t>Now let us check what you have understood. Question 1: Give two factors of rapid population growth. Answer in your exercise book.</a:t>
+              <a:t>Let us copy Implications on Natural Resources. Rapid growth has the following effects on natural resources. On this slide we have Land. Write each point on a new line, with the key term first, and explain it in your own words when we revise.</a:t>
             </a:r>
             <a:endParaRPr lang="en-US" dirty="0"/>
           </a:p>
@@ -3632,7 +3635,7 @@
           <a:p>
             <a:r>
               <a:rPr lang="en-US" dirty="0"/>
-              <a:t>The expected answer is: a high birth rate and a falling death rate. If you got it right, well done.</a:t>
+              <a:t>Copy the point on Forests on the left, then draw the diagram on the right: forest cleared for farms. Give it a title and label it clearly.</a:t>
             </a:r>
             <a:endParaRPr lang="en-US" dirty="0"/>
           </a:p>
@@ -3720,7 +3723,7 @@
           <a:p>
             <a:r>
               <a:rPr lang="en-US" dirty="0"/>
-              <a:t>Now let us check what you have understood. Question 2: Give two effects on natural resources. Answer in your exercise book.</a:t>
+              <a:t>We continue with Implications on Natural Resources. On this slide we have Water and Soils. Write each point on a new line, with the key term first, and explain it in your own words when we revise.</a:t>
             </a:r>
             <a:endParaRPr lang="en-US" dirty="0"/>
           </a:p>
@@ -3808,7 +3811,7 @@
           <a:p>
             <a:r>
               <a:rPr lang="en-US" dirty="0"/>
-              <a:t>The expected answer is: deforestation and shortage of land. If you got it right, well done.</a:t>
+              <a:t>Now let us check what you have understood. Question 1: Give two factors of rapid population growth. Answer in your exercise book.</a:t>
             </a:r>
             <a:endParaRPr lang="en-US" dirty="0"/>
           </a:p>
@@ -3896,7 +3899,7 @@
           <a:p>
             <a:r>
               <a:rPr lang="en-US" dirty="0"/>
-              <a:t>For those who need more practice, fill in the blanks in your exercise book. The answers are: number 1, 8; number 2, growth; number 3, death.</a:t>
+              <a:t>The expected answer is: a high birth rate and a falling death rate. If you got it right, well done.</a:t>
             </a:r>
             <a:endParaRPr lang="en-US" dirty="0"/>
           </a:p>
@@ -3984,7 +3987,7 @@
           <a:p>
             <a:r>
               <a:rPr lang="en-US" dirty="0"/>
-              <a:t>For your homework: Ask your parents how many brothers and sisters they had and compare with families today. We shall correct it at the beginning of our next lesson.</a:t>
+              <a:t>Now let us check what you have understood. Question 2: Give two effects on natural resources. Answer in your exercise book.</a:t>
             </a:r>
             <a:endParaRPr lang="en-US" dirty="0"/>
           </a:p>
@@ -4072,7 +4075,7 @@
           <a:p>
             <a:r>
               <a:rPr lang="en-US" dirty="0"/>
-              <a:t>Our next lesson will be on Practical Work 1: Calculation of the Demographic Indices of Cameroon. Thank you for your attention, and see you next time.</a:t>
+              <a:t>The expected answer is: deforestation and shortage of land. If you got it right, well done.</a:t>
             </a:r>
             <a:endParaRPr lang="en-US" dirty="0"/>
           </a:p>
@@ -4160,7 +4163,7 @@
           <a:p>
             <a:r>
               <a:rPr lang="en-US" dirty="0"/>
-              <a:t>Let us play the bilingual game. I say a word in English, and you give me the French word. Then we do the reverse.</a:t>
+              <a:t>For those who need more practice, fill in the blanks in your exercise book. The answers are: number 1, 8; number 2, growth; number 3, death.</a:t>
             </a:r>
             <a:endParaRPr lang="en-US" dirty="0"/>
           </a:p>
@@ -4248,7 +4251,7 @@
           <a:p>
             <a:r>
               <a:rPr lang="en-US" dirty="0"/>
-              <a:t>I record this information in the official logbook of the class after the lesson.</a:t>
+              <a:t>For your homework: Ask your parents how many brothers and sisters they had and compare with families today. We shall correct it at the beginning of our next lesson.</a:t>
             </a:r>
             <a:endParaRPr lang="en-US" dirty="0"/>
           </a:p>
@@ -4336,7 +4339,7 @@
           <a:p>
             <a:r>
               <a:rPr lang="en-US" dirty="0"/>
-              <a:t>I complete the second page of the logbook: the matter taught, the evaluation, the homework and the attendance.</a:t>
+              <a:t>Our next lesson will be on Practical Work 1: Calculation of the Demographic Indices of Cameroon. Thank you for your attention, and see you next time.</a:t>
             </a:r>
             <a:endParaRPr lang="en-US" dirty="0"/>
           </a:p>
@@ -4512,7 +4515,7 @@
           <a:p>
             <a:r>
               <a:rPr lang="en-US" dirty="0"/>
-              <a:t>This slide is for me, the teacher: it gives the timing of the lesson and what to do if the projector is not available.</a:t>
+              <a:t>Let us play the bilingual game. I say a word in English, and you give me the French word. Then we do the reverse.</a:t>
             </a:r>
             <a:endParaRPr lang="en-US" dirty="0"/>
           </a:p>
@@ -4600,7 +4603,7 @@
           <a:p>
             <a:r>
               <a:rPr lang="en-US" dirty="0"/>
-              <a:t>These are the references and picture credits used to prepare this lesson.</a:t>
+              <a:t>I record this information in the official logbook of the class after the lesson.</a:t>
             </a:r>
             <a:endParaRPr lang="en-US" dirty="0"/>
           </a:p>
@@ -4624,6 +4627,270 @@
             <a:fld id="{F7021451-1387-4CA6-816F-3879F97B5CBC}" type="slidenum">
               <a:rPr lang="en-US"/>
               <a:t>51</a:t>
+            </a:fld>
+            <a:endParaRPr lang="en-US"/>
+          </a:p>
+        </p:txBody>
+      </p:sp>
+    </p:spTree>
+    <p:extLst>
+      <p:ext uri="{BB962C8B-B14F-4D97-AF65-F5344CB8AC3E}">
+        <p14:creationId xmlns:p14="http://schemas.microsoft.com/office/powerpoint/2010/main" val="1024086991"/>
+      </p:ext>
+    </p:extLst>
+  </p:cSld>
+  <p:clrMapOvr>
+    <a:masterClrMapping/>
+  </p:clrMapOvr>
+</p:notes>
+</file>
+
+<file path=ppt/notesSlides/notesSlide52.xml><?xml version="1.0" encoding="utf-8"?>
+<p:notes xmlns:a="http://schemas.openxmlformats.org/drawingml/2006/main" xmlns:r="http://schemas.openxmlformats.org/officeDocument/2006/relationships" xmlns:p="http://schemas.openxmlformats.org/presentationml/2006/main">
+  <p:cSld>
+    <p:spTree>
+      <p:nvGrpSpPr>
+        <p:cNvPr id="1" name=""/>
+        <p:cNvGrpSpPr/>
+        <p:nvPr/>
+      </p:nvGrpSpPr>
+      <p:grpSpPr>
+        <a:xfrm>
+          <a:off x="0" y="0"/>
+          <a:ext cx="0" cy="0"/>
+          <a:chOff x="0" y="0"/>
+          <a:chExt cx="0" cy="0"/>
+        </a:xfrm>
+      </p:grpSpPr>
+      <p:sp>
+        <p:nvSpPr>
+          <p:cNvPr id="2" name="Slide Image Placeholder 1"/>
+          <p:cNvSpPr>
+            <a:spLocks noGrp="1" noRot="1" noChangeAspect="1"/>
+          </p:cNvSpPr>
+          <p:nvPr>
+            <p:ph type="sldImg"/>
+          </p:nvPr>
+        </p:nvSpPr>
+        <p:spPr/>
+      </p:sp>
+      <p:sp>
+        <p:nvSpPr>
+          <p:cNvPr id="3" name="Notes Placeholder 2"/>
+          <p:cNvSpPr>
+            <a:spLocks noGrp="1"/>
+          </p:cNvSpPr>
+          <p:nvPr>
+            <p:ph type="body" idx="1"/>
+          </p:nvPr>
+        </p:nvSpPr>
+        <p:spPr/>
+        <p:txBody>
+          <a:bodyPr/>
+          <a:lstStyle/>
+          <a:p>
+            <a:r>
+              <a:rPr lang="en-US" dirty="0"/>
+              <a:t>I complete the second page of the logbook: the matter taught, the evaluation, the homework and the attendance.</a:t>
+            </a:r>
+            <a:endParaRPr lang="en-US" dirty="0"/>
+          </a:p>
+        </p:txBody>
+      </p:sp>
+      <p:sp>
+        <p:nvSpPr>
+          <p:cNvPr id="4" name="Slide Number Placeholder 3"/>
+          <p:cNvSpPr>
+            <a:spLocks noGrp="1"/>
+          </p:cNvSpPr>
+          <p:nvPr>
+            <p:ph type="sldNum" sz="quarter" idx="10"/>
+          </p:nvPr>
+        </p:nvSpPr>
+        <p:spPr/>
+        <p:txBody>
+          <a:bodyPr/>
+          <a:lstStyle/>
+          <a:p>
+            <a:fld id="{F7021451-1387-4CA6-816F-3879F97B5CBC}" type="slidenum">
+              <a:rPr lang="en-US"/>
+              <a:t>52</a:t>
+            </a:fld>
+            <a:endParaRPr lang="en-US"/>
+          </a:p>
+        </p:txBody>
+      </p:sp>
+    </p:spTree>
+    <p:extLst>
+      <p:ext uri="{BB962C8B-B14F-4D97-AF65-F5344CB8AC3E}">
+        <p14:creationId xmlns:p14="http://schemas.microsoft.com/office/powerpoint/2010/main" val="1024086991"/>
+      </p:ext>
+    </p:extLst>
+  </p:cSld>
+  <p:clrMapOvr>
+    <a:masterClrMapping/>
+  </p:clrMapOvr>
+</p:notes>
+</file>
+
+<file path=ppt/notesSlides/notesSlide53.xml><?xml version="1.0" encoding="utf-8"?>
+<p:notes xmlns:a="http://schemas.openxmlformats.org/drawingml/2006/main" xmlns:r="http://schemas.openxmlformats.org/officeDocument/2006/relationships" xmlns:p="http://schemas.openxmlformats.org/presentationml/2006/main">
+  <p:cSld>
+    <p:spTree>
+      <p:nvGrpSpPr>
+        <p:cNvPr id="1" name=""/>
+        <p:cNvGrpSpPr/>
+        <p:nvPr/>
+      </p:nvGrpSpPr>
+      <p:grpSpPr>
+        <a:xfrm>
+          <a:off x="0" y="0"/>
+          <a:ext cx="0" cy="0"/>
+          <a:chOff x="0" y="0"/>
+          <a:chExt cx="0" cy="0"/>
+        </a:xfrm>
+      </p:grpSpPr>
+      <p:sp>
+        <p:nvSpPr>
+          <p:cNvPr id="2" name="Slide Image Placeholder 1"/>
+          <p:cNvSpPr>
+            <a:spLocks noGrp="1" noRot="1" noChangeAspect="1"/>
+          </p:cNvSpPr>
+          <p:nvPr>
+            <p:ph type="sldImg"/>
+          </p:nvPr>
+        </p:nvSpPr>
+        <p:spPr/>
+      </p:sp>
+      <p:sp>
+        <p:nvSpPr>
+          <p:cNvPr id="3" name="Notes Placeholder 2"/>
+          <p:cNvSpPr>
+            <a:spLocks noGrp="1"/>
+          </p:cNvSpPr>
+          <p:nvPr>
+            <p:ph type="body" idx="1"/>
+          </p:nvPr>
+        </p:nvSpPr>
+        <p:spPr/>
+        <p:txBody>
+          <a:bodyPr/>
+          <a:lstStyle/>
+          <a:p>
+            <a:r>
+              <a:rPr lang="en-US" dirty="0"/>
+              <a:t>This slide is for me, the teacher: it gives the timing of the lesson and what to do if the projector is not available.</a:t>
+            </a:r>
+            <a:endParaRPr lang="en-US" dirty="0"/>
+          </a:p>
+        </p:txBody>
+      </p:sp>
+      <p:sp>
+        <p:nvSpPr>
+          <p:cNvPr id="4" name="Slide Number Placeholder 3"/>
+          <p:cNvSpPr>
+            <a:spLocks noGrp="1"/>
+          </p:cNvSpPr>
+          <p:nvPr>
+            <p:ph type="sldNum" sz="quarter" idx="10"/>
+          </p:nvPr>
+        </p:nvSpPr>
+        <p:spPr/>
+        <p:txBody>
+          <a:bodyPr/>
+          <a:lstStyle/>
+          <a:p>
+            <a:fld id="{F7021451-1387-4CA6-816F-3879F97B5CBC}" type="slidenum">
+              <a:rPr lang="en-US"/>
+              <a:t>53</a:t>
+            </a:fld>
+            <a:endParaRPr lang="en-US"/>
+          </a:p>
+        </p:txBody>
+      </p:sp>
+    </p:spTree>
+    <p:extLst>
+      <p:ext uri="{BB962C8B-B14F-4D97-AF65-F5344CB8AC3E}">
+        <p14:creationId xmlns:p14="http://schemas.microsoft.com/office/powerpoint/2010/main" val="1024086991"/>
+      </p:ext>
+    </p:extLst>
+  </p:cSld>
+  <p:clrMapOvr>
+    <a:masterClrMapping/>
+  </p:clrMapOvr>
+</p:notes>
+</file>
+
+<file path=ppt/notesSlides/notesSlide54.xml><?xml version="1.0" encoding="utf-8"?>
+<p:notes xmlns:a="http://schemas.openxmlformats.org/drawingml/2006/main" xmlns:r="http://schemas.openxmlformats.org/officeDocument/2006/relationships" xmlns:p="http://schemas.openxmlformats.org/presentationml/2006/main">
+  <p:cSld>
+    <p:spTree>
+      <p:nvGrpSpPr>
+        <p:cNvPr id="1" name=""/>
+        <p:cNvGrpSpPr/>
+        <p:nvPr/>
+      </p:nvGrpSpPr>
+      <p:grpSpPr>
+        <a:xfrm>
+          <a:off x="0" y="0"/>
+          <a:ext cx="0" cy="0"/>
+          <a:chOff x="0" y="0"/>
+          <a:chExt cx="0" cy="0"/>
+        </a:xfrm>
+      </p:grpSpPr>
+      <p:sp>
+        <p:nvSpPr>
+          <p:cNvPr id="2" name="Slide Image Placeholder 1"/>
+          <p:cNvSpPr>
+            <a:spLocks noGrp="1" noRot="1" noChangeAspect="1"/>
+          </p:cNvSpPr>
+          <p:nvPr>
+            <p:ph type="sldImg"/>
+          </p:nvPr>
+        </p:nvSpPr>
+        <p:spPr/>
+      </p:sp>
+      <p:sp>
+        <p:nvSpPr>
+          <p:cNvPr id="3" name="Notes Placeholder 2"/>
+          <p:cNvSpPr>
+            <a:spLocks noGrp="1"/>
+          </p:cNvSpPr>
+          <p:nvPr>
+            <p:ph type="body" idx="1"/>
+          </p:nvPr>
+        </p:nvSpPr>
+        <p:spPr/>
+        <p:txBody>
+          <a:bodyPr/>
+          <a:lstStyle/>
+          <a:p>
+            <a:r>
+              <a:rPr lang="en-US" dirty="0"/>
+              <a:t>These are the references and picture credits used to prepare this lesson.</a:t>
+            </a:r>
+            <a:endParaRPr lang="en-US" dirty="0"/>
+          </a:p>
+        </p:txBody>
+      </p:sp>
+      <p:sp>
+        <p:nvSpPr>
+          <p:cNvPr id="4" name="Slide Number Placeholder 3"/>
+          <p:cNvSpPr>
+            <a:spLocks noGrp="1"/>
+          </p:cNvSpPr>
+          <p:nvPr>
+            <p:ph type="sldNum" sz="quarter" idx="10"/>
+          </p:nvPr>
+        </p:nvSpPr>
+        <p:spPr/>
+        <p:txBody>
+          <a:bodyPr/>
+          <a:lstStyle/>
+          <a:p>
+            <a:fld id="{F7021451-1387-4CA6-816F-3879F97B5CBC}" type="slidenum">
+              <a:rPr lang="en-US"/>
+              <a:t>54</a:t>
             </a:fld>
             <a:endParaRPr lang="en-US"/>
           </a:p>
@@ -4864,7 +5131,7 @@
           <a:p>
             <a:r>
               <a:rPr lang="en-US" dirty="0"/>
-              <a:t>Listen carefully to this situation from real life. Grandmother Hawa says that when she was young, her village had only a few compounds and plenty of land. Today the village is crowded, the forest has disappeared and farms are small. Think about it, because I am going to ask you some questions.</a:t>
+              <a:t>Listen carefully to this situation from real life. Grandmother Hawa says that when she was young, her village had only a few compounds and plenty of land. Today the village is crowded, the forest has disappeared and the farms are small. Her grandson asks: "Why are there so many more people today, and what will happen to our land?" Think about it, because I am going to ask you some questions.</a:t>
             </a:r>
             <a:endParaRPr lang="en-US" dirty="0"/>
           </a:p>
@@ -6416,7 +6683,7 @@
                 <a:ea typeface="Times New Roman" pitchFamily="34" charset="-122"/>
                 <a:cs typeface="Times New Roman" pitchFamily="34" charset="-120"/>
               </a:rPr>
-              <a:t>The population of the village has grown quickly.</a:t>
+              <a:t>The grandson does not know why the population has grown so fast and what it means for the land.</a:t>
             </a:r>
             <a:endParaRPr lang="en-US" sz="4000" dirty="0"/>
           </a:p>
@@ -7292,7 +7559,7 @@
                 <a:ea typeface="Times New Roman" pitchFamily="34" charset="-122"/>
                 <a:cs typeface="Times New Roman" pitchFamily="34" charset="-120"/>
               </a:rPr>
-              <a:t>There are more people sharing the same land.</a:t>
+              <a:t>More people share the same land.</a:t>
             </a:r>
             <a:endParaRPr lang="en-US" sz="4000" dirty="0"/>
           </a:p>
@@ -8163,7 +8430,7 @@
                 <a:ea typeface="Times New Roman" pitchFamily="34" charset="-122"/>
                 <a:cs typeface="Times New Roman" pitchFamily="34" charset="-120"/>
               </a:rPr>
-              <a:t>How many people lived on the Earth in 1800 and in 2022?</a:t>
+              <a:t>About how many people lived on the Earth in 1800?</a:t>
             </a:r>
             <a:endParaRPr lang="en-US" sz="4000" dirty="0"/>
           </a:p>
@@ -8382,7 +8649,7 @@
                 <a:ea typeface="Times New Roman" pitchFamily="34" charset="-122"/>
                 <a:cs typeface="Times New Roman" pitchFamily="34" charset="-120"/>
               </a:rPr>
-              <a:t>About 1 billion in 1800 and 8 billion in 2022.</a:t>
+              <a:t>About 1 billion.</a:t>
             </a:r>
             <a:endParaRPr lang="en-US" sz="4000" dirty="0"/>
           </a:p>
@@ -9136,7 +9403,7 @@
       </p:sp>
       <p:pic>
         <p:nvPicPr>
-          <p:cNvPr id="4" name="Image 0" descr="/home/claude/f4/img/v2/usa_crowd.jpg">    </p:cNvPr>
+          <p:cNvPr id="4" name="Image 0" descr="/home/claude/f4/img/v2/world_growth_big.png">    </p:cNvPr>
           <p:cNvPicPr>
             <a:picLocks noChangeAspect="1"/>
           </p:cNvPicPr>
@@ -9150,8 +9417,8 @@
         </p:blipFill>
         <p:spPr>
           <a:xfrm>
-            <a:off x="2246610" y="1783080"/>
-            <a:ext cx="7698475" cy="4270248"/>
+            <a:off x="1215564" y="1783080"/>
+            <a:ext cx="9760567" cy="4270248"/>
           </a:xfrm>
           <a:prstGeom prst="rect">
             <a:avLst/>
@@ -9191,7 +9458,7 @@
                 <a:ea typeface="Times New Roman" pitchFamily="34" charset="-122"/>
                 <a:cs typeface="Times New Roman" pitchFamily="34" charset="-120"/>
               </a:rPr>
-              <a:t>A crowded market.</a:t>
+              <a:t>World population over time.</a:t>
             </a:r>
             <a:endParaRPr lang="en-US" sz="1800" dirty="0"/>
           </a:p>
@@ -9410,7 +9677,7 @@
                 <a:ea typeface="Times New Roman" pitchFamily="34" charset="-122"/>
                 <a:cs typeface="Times New Roman" pitchFamily="34" charset="-120"/>
               </a:rPr>
-              <a:t>Is the world population growing slowly or quickly today?</a:t>
+              <a:t>About how many people live on the Earth today?</a:t>
             </a:r>
             <a:endParaRPr lang="en-US" sz="4000" dirty="0"/>
           </a:p>
@@ -9629,7 +9896,7 @@
                 <a:ea typeface="Times New Roman" pitchFamily="34" charset="-122"/>
                 <a:cs typeface="Times New Roman" pitchFamily="34" charset="-120"/>
               </a:rPr>
-              <a:t>Quickly: it has grown very fast since about 1950.</a:t>
+              <a:t>More than 8 billion: the population has grown very fast since 1950.</a:t>
             </a:r>
             <a:endParaRPr lang="en-US" sz="4000" dirty="0"/>
           </a:p>
@@ -10495,7 +10762,7 @@
                 <a:ea typeface="Times New Roman" pitchFamily="34" charset="-122"/>
                 <a:cs typeface="Times New Roman" pitchFamily="34" charset="-120"/>
               </a:rPr>
-              <a:t>Birth rate and death rate.</a:t>
+              <a:t>Births and deaths.</a:t>
             </a:r>
             <a:endParaRPr lang="en-US" sz="1800" dirty="0"/>
           </a:p>
@@ -10933,7 +11200,7 @@
                 <a:ea typeface="Times New Roman" pitchFamily="34" charset="-122"/>
                 <a:cs typeface="Times New Roman" pitchFamily="34" charset="-120"/>
               </a:rPr>
-              <a:t>The population grows (natural increase).</a:t>
+              <a:t>The population grows: this is natural growth.</a:t>
             </a:r>
             <a:endParaRPr lang="en-US" sz="4000" dirty="0"/>
           </a:p>
@@ -11830,7 +12097,7 @@
                           <a:ea typeface="Calibri" pitchFamily="34" charset="-122"/>
                           <a:cs typeface="Calibri" pitchFamily="34" charset="-120"/>
                         </a:rPr>
-                        <a:t>Population, natural population growth, birth rate, death rate, resources.</a:t>
+                        <a:t>Population, natural population growth, resources.</a:t>
                       </a:r>
                       <a:endParaRPr lang="en-US" sz="1700" dirty="0">
                         <a:latin typeface="Calibri" charset="0"/>
@@ -11968,7 +12235,7 @@
                           <a:ea typeface="Calibri" pitchFamily="34" charset="-122"/>
                           <a:cs typeface="Calibri" pitchFamily="34" charset="-120"/>
                         </a:rPr>
-                        <a:t>Evolution of the world's population; factors of population growth; implications of rapid population growth on natural resources.</a:t>
+                        <a:t>Evolution of the world's population; factors of the population growth; implications of the rapid population growth on natural resources.</a:t>
                       </a:r>
                       <a:endParaRPr lang="en-US" sz="1700" dirty="0">
                         <a:latin typeface="Calibri" charset="0"/>
@@ -12375,7 +12642,7 @@
                 <a:ea typeface="Times New Roman" pitchFamily="34" charset="-122"/>
                 <a:cs typeface="Times New Roman" pitchFamily="34" charset="-120"/>
               </a:rPr>
-              <a:t>Give two effects of rapid population growth on natural resources.</a:t>
+              <a:t>Why is the forest cut when the population grows?</a:t>
             </a:r>
             <a:endParaRPr lang="en-US" sz="4000" dirty="0"/>
           </a:p>
@@ -12594,7 +12861,7 @@
                 <a:ea typeface="Times New Roman" pitchFamily="34" charset="-122"/>
                 <a:cs typeface="Times New Roman" pitchFamily="34" charset="-120"/>
               </a:rPr>
-              <a:t>Forests are cut for farms and firewood; land and water become scarce.</a:t>
+              <a:t>More people need more land for farms and more wood for fuel and houses.</a:t>
             </a:r>
             <a:endParaRPr lang="en-US" sz="4000" dirty="0"/>
           </a:p>
@@ -12988,7 +13255,7 @@
         <p:spPr>
           <a:xfrm>
             <a:off x="0" y="658368"/>
-            <a:ext cx="3840480" cy="5833872"/>
+            <a:ext cx="2468880" cy="5833872"/>
           </a:xfrm>
           <a:prstGeom prst="rect">
             <a:avLst/>
@@ -13003,8 +13270,8 @@
         </p:nvSpPr>
         <p:spPr>
           <a:xfrm>
-            <a:off x="4069080" y="1005840"/>
-            <a:ext cx="7802575" cy="731520"/>
+            <a:off x="2697480" y="1005840"/>
+            <a:ext cx="9174175" cy="731520"/>
           </a:xfrm>
           <a:prstGeom prst="rect">
             <a:avLst/>
@@ -13044,8 +13311,8 @@
         </p:nvSpPr>
         <p:spPr>
           <a:xfrm>
-            <a:off x="4069080" y="1783080"/>
-            <a:ext cx="7802575" cy="4663440"/>
+            <a:off x="2697480" y="1783080"/>
+            <a:ext cx="9174175" cy="4663440"/>
           </a:xfrm>
           <a:prstGeom prst="rect">
             <a:avLst/>
@@ -13109,7 +13376,7 @@
                 <a:ea typeface="Times New Roman" pitchFamily="34" charset="-122"/>
                 <a:cs typeface="Times New Roman" pitchFamily="34" charset="-120"/>
               </a:rPr>
-              <a:t>It is the number of people living in a place.</a:t>
+              <a:t>It is the number of people living in a place at a given time.</a:t>
             </a:r>
             <a:endParaRPr lang="en-US" sz="4000" dirty="0"/>
           </a:p>
@@ -13129,7 +13396,7 @@
                 <a:ea typeface="Times New Roman" pitchFamily="34" charset="-122"/>
                 <a:cs typeface="Times New Roman" pitchFamily="34" charset="-120"/>
               </a:rPr>
-              <a:t>Natural growth: </a:t>
+              <a:t>Natural population growth: </a:t>
             </a:r>
             <a:pPr algn="l" indent="0" marL="0">
               <a:spcAft>
@@ -13281,7 +13548,7 @@
         <p:spPr>
           <a:xfrm>
             <a:off x="0" y="658368"/>
-            <a:ext cx="2468880" cy="5833872"/>
+            <a:ext cx="5120640" cy="5833872"/>
           </a:xfrm>
           <a:prstGeom prst="rect">
             <a:avLst/>
@@ -13296,8 +13563,8 @@
         </p:nvSpPr>
         <p:spPr>
           <a:xfrm>
-            <a:off x="2697480" y="1005840"/>
-            <a:ext cx="9174175" cy="731520"/>
+            <a:off x="5349240" y="1005840"/>
+            <a:ext cx="6522415" cy="731520"/>
           </a:xfrm>
           <a:prstGeom prst="rect">
             <a:avLst/>
@@ -13323,7 +13590,7 @@
                 <a:ea typeface="Times New Roman" pitchFamily="34" charset="-122"/>
                 <a:cs typeface="Times New Roman" pitchFamily="34" charset="-120"/>
               </a:rPr>
-              <a:t>1. Evolution of the World's Population</a:t>
+              <a:t>DEFINITIONS (continued)</a:t>
             </a:r>
             <a:endParaRPr lang="en-US" sz="3600" dirty="0"/>
           </a:p>
@@ -13337,8 +13604,8 @@
         </p:nvSpPr>
         <p:spPr>
           <a:xfrm>
-            <a:off x="2697480" y="1783080"/>
-            <a:ext cx="9174175" cy="4663440"/>
+            <a:off x="5349240" y="1783080"/>
+            <a:ext cx="6522415" cy="4663440"/>
           </a:xfrm>
           <a:prstGeom prst="rect">
             <a:avLst/>
@@ -13357,7 +13624,7 @@
               <a:buNone/>
             </a:pPr>
             <a:r>
-              <a:rPr lang="en-US" sz="4000" i="1" dirty="0">
+              <a:rPr lang="en-US" sz="4000" b="1" dirty="0">
                 <a:solidFill>
                   <a:srgbClr val="111111"/>
                 </a:solidFill>
@@ -13365,11 +13632,8 @@
                 <a:ea typeface="Times New Roman" pitchFamily="34" charset="-122"/>
                 <a:cs typeface="Times New Roman" pitchFamily="34" charset="-120"/>
               </a:rPr>
-              <a:t>The world population has grown as follows:</a:t>
-            </a:r>
-            <a:endParaRPr lang="en-US" sz="4000" dirty="0"/>
-          </a:p>
-          <a:p>
+              <a:t>Resources: </a:t>
+            </a:r>
             <a:pPr algn="l" indent="0" marL="0">
               <a:spcAft>
                 <a:spcPts val="800"/>
@@ -13377,7 +13641,7 @@
               <a:buNone/>
             </a:pPr>
             <a:r>
-              <a:rPr lang="en-US" sz="4000" b="1" dirty="0">
+              <a:rPr lang="en-US" sz="4000" dirty="0">
                 <a:solidFill>
                   <a:srgbClr val="111111"/>
                 </a:solidFill>
@@ -13385,61 +13649,7 @@
                 <a:ea typeface="Times New Roman" pitchFamily="34" charset="-122"/>
                 <a:cs typeface="Times New Roman" pitchFamily="34" charset="-120"/>
               </a:rPr>
-              <a:t>Slow growth: </a:t>
-            </a:r>
-            <a:pPr algn="l" indent="0" marL="0">
-              <a:spcAft>
-                <a:spcPts val="800"/>
-              </a:spcAft>
-              <a:buNone/>
-            </a:pPr>
-            <a:r>
-              <a:rPr lang="en-US" sz="4000" dirty="0">
-                <a:solidFill>
-                  <a:srgbClr val="111111"/>
-                </a:solidFill>
-                <a:latin typeface="Times New Roman" pitchFamily="34" charset="0"/>
-                <a:ea typeface="Times New Roman" pitchFamily="34" charset="-122"/>
-                <a:cs typeface="Times New Roman" pitchFamily="34" charset="-120"/>
-              </a:rPr>
-              <a:t>The world had fewer than 1 billion people until about 1800.</a:t>
-            </a:r>
-            <a:endParaRPr lang="en-US" sz="4000" dirty="0"/>
-          </a:p>
-          <a:p>
-            <a:pPr algn="l" indent="0" marL="0">
-              <a:spcAft>
-                <a:spcPts val="800"/>
-              </a:spcAft>
-              <a:buNone/>
-            </a:pPr>
-            <a:r>
-              <a:rPr lang="en-US" sz="4000" b="1" dirty="0">
-                <a:solidFill>
-                  <a:srgbClr val="111111"/>
-                </a:solidFill>
-                <a:latin typeface="Times New Roman" pitchFamily="34" charset="0"/>
-                <a:ea typeface="Times New Roman" pitchFamily="34" charset="-122"/>
-                <a:cs typeface="Times New Roman" pitchFamily="34" charset="-120"/>
-              </a:rPr>
-              <a:t>Rapid growth: </a:t>
-            </a:r>
-            <a:pPr algn="l" indent="0" marL="0">
-              <a:spcAft>
-                <a:spcPts val="800"/>
-              </a:spcAft>
-              <a:buNone/>
-            </a:pPr>
-            <a:r>
-              <a:rPr lang="en-US" sz="4000" dirty="0">
-                <a:solidFill>
-                  <a:srgbClr val="111111"/>
-                </a:solidFill>
-                <a:latin typeface="Times New Roman" pitchFamily="34" charset="0"/>
-                <a:ea typeface="Times New Roman" pitchFamily="34" charset="-122"/>
-                <a:cs typeface="Times New Roman" pitchFamily="34" charset="-120"/>
-              </a:rPr>
-              <a:t>The population reached 8 billion in 2022, growing fastest after 1950.</a:t>
+              <a:t>They are the useful things that people get from nature, such as land, water and forests.</a:t>
             </a:r>
             <a:endParaRPr lang="en-US" sz="4000" dirty="0"/>
           </a:p>
@@ -13557,48 +13767,9 @@
           </a:p>
         </p:txBody>
       </p:sp>
-      <p:sp>
-        <p:nvSpPr>
-          <p:cNvPr id="3" name="Text 1"/>
-          <p:cNvSpPr/>
-          <p:nvPr/>
-        </p:nvSpPr>
-        <p:spPr>
-          <a:xfrm>
-            <a:off x="457200" y="1005840"/>
-            <a:ext cx="11277295" cy="731520"/>
-          </a:xfrm>
-          <a:prstGeom prst="rect">
-            <a:avLst/>
-          </a:prstGeom>
-          <a:noFill/>
-          <a:ln/>
-        </p:spPr>
-        <p:txBody>
-          <a:bodyPr wrap="square" lIns="0" tIns="0" rIns="0" bIns="0" rtlCol="0" anchor="ctr"/>
-          <a:lstStyle/>
-          <a:p>
-            <a:pPr algn="ctr" indent="0" marL="0">
-              <a:buNone/>
-            </a:pPr>
-            <a:r>
-              <a:rPr lang="en-US" sz="3600" b="1" dirty="0">
-                <a:solidFill>
-                  <a:srgbClr val="990011"/>
-                </a:solidFill>
-                <a:latin typeface="Times New Roman" pitchFamily="34" charset="0"/>
-                <a:ea typeface="Times New Roman" pitchFamily="34" charset="-122"/>
-                <a:cs typeface="Times New Roman" pitchFamily="34" charset="-120"/>
-              </a:rPr>
-              <a:t>1. Evolution of the World's Population</a:t>
-            </a:r>
-            <a:endParaRPr lang="en-US" sz="3600" dirty="0"/>
-          </a:p>
-        </p:txBody>
-      </p:sp>
       <p:pic>
         <p:nvPicPr>
-          <p:cNvPr id="4" name="Image 0" descr="/home/claude/f4/img/v2/world_growth_big.png">    </p:cNvPr>
+          <p:cNvPr id="3" name="Image 0" descr="/home/claude/f4/img/minesec_sheet.png">    </p:cNvPr>
           <p:cNvPicPr>
             <a:picLocks noChangeAspect="1"/>
           </p:cNvPicPr>
@@ -13612,8 +13783,8 @@
         </p:blipFill>
         <p:spPr>
           <a:xfrm>
-            <a:off x="1215564" y="1783080"/>
-            <a:ext cx="9760567" cy="4270248"/>
+            <a:off x="0" y="658368"/>
+            <a:ext cx="2468880" cy="5833872"/>
           </a:xfrm>
           <a:prstGeom prst="rect">
             <a:avLst/>
@@ -13622,14 +13793,14 @@
       </p:pic>
       <p:sp>
         <p:nvSpPr>
-          <p:cNvPr id="5" name="Text 2"/>
+          <p:cNvPr id="4" name="Text 1"/>
           <p:cNvSpPr/>
           <p:nvPr/>
         </p:nvSpPr>
         <p:spPr>
           <a:xfrm>
-            <a:off x="457200" y="6089904"/>
-            <a:ext cx="11277295" cy="347472"/>
+            <a:off x="2697480" y="1005840"/>
+            <a:ext cx="9174175" cy="731520"/>
           </a:xfrm>
           <a:prstGeom prst="rect">
             <a:avLst/>
@@ -13638,24 +13809,142 @@
           <a:ln/>
         </p:spPr>
         <p:txBody>
-          <a:bodyPr wrap="square" lIns="0" tIns="0" rIns="0" bIns="0" rtlCol="0" anchor="ctr"/>
+          <a:bodyPr wrap="square" lIns="0" tIns="0" rIns="0" bIns="0" rtlCol="0" anchor="ctr">
+            <a:normAutofit/>
+          </a:bodyPr>
           <a:lstStyle/>
           <a:p>
             <a:pPr algn="ctr" indent="0" marL="0">
               <a:buNone/>
             </a:pPr>
             <a:r>
-              <a:rPr lang="en-US" sz="1800" i="1" dirty="0">
-                <a:solidFill>
-                  <a:srgbClr val="555555"/>
+              <a:rPr lang="en-US" sz="3600" b="1" dirty="0">
+                <a:solidFill>
+                  <a:srgbClr val="990011"/>
                 </a:solidFill>
                 <a:latin typeface="Times New Roman" pitchFamily="34" charset="0"/>
                 <a:ea typeface="Times New Roman" pitchFamily="34" charset="-122"/>
                 <a:cs typeface="Times New Roman" pitchFamily="34" charset="-120"/>
               </a:rPr>
-              <a:t>Illustration: world population growth</a:t>
-            </a:r>
-            <a:endParaRPr lang="en-US" sz="1800" dirty="0"/>
+              <a:t>1. Evolution of the World's Population</a:t>
+            </a:r>
+            <a:endParaRPr lang="en-US" sz="3600" dirty="0"/>
+          </a:p>
+        </p:txBody>
+      </p:sp>
+      <p:sp>
+        <p:nvSpPr>
+          <p:cNvPr id="5" name="Text 2"/>
+          <p:cNvSpPr/>
+          <p:nvPr/>
+        </p:nvSpPr>
+        <p:spPr>
+          <a:xfrm>
+            <a:off x="2697480" y="1783080"/>
+            <a:ext cx="9174175" cy="4663440"/>
+          </a:xfrm>
+          <a:prstGeom prst="rect">
+            <a:avLst/>
+          </a:prstGeom>
+          <a:noFill/>
+          <a:ln/>
+        </p:spPr>
+        <p:txBody>
+          <a:bodyPr wrap="square" lIns="0" tIns="0" rIns="0" bIns="0" rtlCol="0" anchor="t"/>
+          <a:lstStyle/>
+          <a:p>
+            <a:pPr algn="l" indent="0" marL="0">
+              <a:spcAft>
+                <a:spcPts val="800"/>
+              </a:spcAft>
+              <a:buNone/>
+            </a:pPr>
+            <a:r>
+              <a:rPr lang="en-US" sz="4000" i="1" dirty="0">
+                <a:solidFill>
+                  <a:srgbClr val="111111"/>
+                </a:solidFill>
+                <a:latin typeface="Times New Roman" pitchFamily="34" charset="0"/>
+                <a:ea typeface="Times New Roman" pitchFamily="34" charset="-122"/>
+                <a:cs typeface="Times New Roman" pitchFamily="34" charset="-120"/>
+              </a:rPr>
+              <a:t>The world population has evolved as follows:</a:t>
+            </a:r>
+            <a:endParaRPr lang="en-US" sz="4000" dirty="0"/>
+          </a:p>
+          <a:p>
+            <a:pPr algn="l" indent="0" marL="0">
+              <a:spcAft>
+                <a:spcPts val="800"/>
+              </a:spcAft>
+              <a:buNone/>
+            </a:pPr>
+            <a:r>
+              <a:rPr lang="en-US" sz="4000" b="1" dirty="0">
+                <a:solidFill>
+                  <a:srgbClr val="111111"/>
+                </a:solidFill>
+                <a:latin typeface="Times New Roman" pitchFamily="34" charset="0"/>
+                <a:ea typeface="Times New Roman" pitchFamily="34" charset="-122"/>
+                <a:cs typeface="Times New Roman" pitchFamily="34" charset="-120"/>
+              </a:rPr>
+              <a:t>Slow growth: </a:t>
+            </a:r>
+            <a:pPr algn="l" indent="0" marL="0">
+              <a:spcAft>
+                <a:spcPts val="800"/>
+              </a:spcAft>
+              <a:buNone/>
+            </a:pPr>
+            <a:r>
+              <a:rPr lang="en-US" sz="4000" dirty="0">
+                <a:solidFill>
+                  <a:srgbClr val="111111"/>
+                </a:solidFill>
+                <a:latin typeface="Times New Roman" pitchFamily="34" charset="0"/>
+                <a:ea typeface="Times New Roman" pitchFamily="34" charset="-122"/>
+                <a:cs typeface="Times New Roman" pitchFamily="34" charset="-120"/>
+              </a:rPr>
+              <a:t>Until about 1800, the world had fewer than 1 billion people because many people died young.</a:t>
+            </a:r>
+            <a:endParaRPr lang="en-US" sz="4000" dirty="0"/>
+          </a:p>
+          <a:p>
+            <a:pPr algn="l" indent="0" marL="0">
+              <a:spcAft>
+                <a:spcPts val="800"/>
+              </a:spcAft>
+              <a:buNone/>
+            </a:pPr>
+            <a:r>
+              <a:rPr lang="en-US" sz="4000" b="1" dirty="0">
+                <a:solidFill>
+                  <a:srgbClr val="111111"/>
+                </a:solidFill>
+                <a:latin typeface="Times New Roman" pitchFamily="34" charset="0"/>
+                <a:ea typeface="Times New Roman" pitchFamily="34" charset="-122"/>
+                <a:cs typeface="Times New Roman" pitchFamily="34" charset="-120"/>
+              </a:rPr>
+              <a:t>Faster growth: </a:t>
+            </a:r>
+            <a:pPr algn="l" indent="0" marL="0">
+              <a:spcAft>
+                <a:spcPts val="800"/>
+              </a:spcAft>
+              <a:buNone/>
+            </a:pPr>
+            <a:r>
+              <a:rPr lang="en-US" sz="4000" dirty="0">
+                <a:solidFill>
+                  <a:srgbClr val="111111"/>
+                </a:solidFill>
+                <a:latin typeface="Times New Roman" pitchFamily="34" charset="0"/>
+                <a:ea typeface="Times New Roman" pitchFamily="34" charset="-122"/>
+                <a:cs typeface="Times New Roman" pitchFamily="34" charset="-120"/>
+              </a:rPr>
+              <a:t>The population reached about 2.5 billion in 1950.</a:t>
+            </a:r>
+            <a:endParaRPr lang="en-US" sz="4000" dirty="0"/>
           </a:p>
         </p:txBody>
       </p:sp>
@@ -13771,9 +14060,109 @@
           </a:p>
         </p:txBody>
       </p:sp>
+      <p:sp>
+        <p:nvSpPr>
+          <p:cNvPr id="3" name="Text 1"/>
+          <p:cNvSpPr/>
+          <p:nvPr/>
+        </p:nvSpPr>
+        <p:spPr>
+          <a:xfrm>
+            <a:off x="365760" y="1005840"/>
+            <a:ext cx="11460175" cy="731520"/>
+          </a:xfrm>
+          <a:prstGeom prst="rect">
+            <a:avLst/>
+          </a:prstGeom>
+          <a:noFill/>
+          <a:ln/>
+        </p:spPr>
+        <p:txBody>
+          <a:bodyPr wrap="square" lIns="0" tIns="0" rIns="0" bIns="0" rtlCol="0" anchor="ctr">
+            <a:normAutofit/>
+          </a:bodyPr>
+          <a:lstStyle/>
+          <a:p>
+            <a:pPr algn="ctr" indent="0" marL="0">
+              <a:buNone/>
+            </a:pPr>
+            <a:r>
+              <a:rPr lang="en-US" sz="3600" b="1" dirty="0">
+                <a:solidFill>
+                  <a:srgbClr val="990011"/>
+                </a:solidFill>
+                <a:latin typeface="Times New Roman" pitchFamily="34" charset="0"/>
+                <a:ea typeface="Times New Roman" pitchFamily="34" charset="-122"/>
+                <a:cs typeface="Times New Roman" pitchFamily="34" charset="-120"/>
+              </a:rPr>
+              <a:t>1. Evolution of the World's Population</a:t>
+            </a:r>
+            <a:endParaRPr lang="en-US" sz="3600" dirty="0"/>
+          </a:p>
+        </p:txBody>
+      </p:sp>
+      <p:sp>
+        <p:nvSpPr>
+          <p:cNvPr id="4" name="Text 2"/>
+          <p:cNvSpPr/>
+          <p:nvPr/>
+        </p:nvSpPr>
+        <p:spPr>
+          <a:xfrm>
+            <a:off x="365760" y="1783080"/>
+            <a:ext cx="4846320" cy="4617720"/>
+          </a:xfrm>
+          <a:prstGeom prst="rect">
+            <a:avLst/>
+          </a:prstGeom>
+          <a:noFill/>
+          <a:ln/>
+        </p:spPr>
+        <p:txBody>
+          <a:bodyPr wrap="square" lIns="0" tIns="0" rIns="0" bIns="0" rtlCol="0" anchor="t"/>
+          <a:lstStyle/>
+          <a:p>
+            <a:pPr algn="l" indent="0" marL="0">
+              <a:spcAft>
+                <a:spcPts val="800"/>
+              </a:spcAft>
+              <a:buNone/>
+            </a:pPr>
+            <a:r>
+              <a:rPr lang="en-US" sz="3600" b="1" dirty="0">
+                <a:solidFill>
+                  <a:srgbClr val="111111"/>
+                </a:solidFill>
+                <a:latin typeface="Times New Roman" pitchFamily="34" charset="0"/>
+                <a:ea typeface="Times New Roman" pitchFamily="34" charset="-122"/>
+                <a:cs typeface="Times New Roman" pitchFamily="34" charset="-120"/>
+              </a:rPr>
+              <a:t>Rapid growth: </a:t>
+            </a:r>
+            <a:pPr algn="l" indent="0" marL="0">
+              <a:spcAft>
+                <a:spcPts val="800"/>
+              </a:spcAft>
+              <a:buNone/>
+            </a:pPr>
+            <a:r>
+              <a:rPr lang="en-US" sz="3600" dirty="0">
+                <a:solidFill>
+                  <a:srgbClr val="111111"/>
+                </a:solidFill>
+                <a:latin typeface="Times New Roman" pitchFamily="34" charset="0"/>
+                <a:ea typeface="Times New Roman" pitchFamily="34" charset="-122"/>
+                <a:cs typeface="Times New Roman" pitchFamily="34" charset="-120"/>
+              </a:rPr>
+              <a:t>It passed 8 billion in 2022, growing fastest in Africa and Asia.</a:t>
+            </a:r>
+            <a:endParaRPr lang="en-US" sz="3600" dirty="0"/>
+          </a:p>
+        </p:txBody>
+      </p:sp>
       <p:pic>
         <p:nvPicPr>
-          <p:cNvPr id="3" name="Image 0" descr="/home/claude/f4/img/minesec_sheet.png">    </p:cNvPr>
+          <p:cNvPr id="5" name="Image 0" descr="/home/claude/f4/img/v2/world_growth_big.png">    </p:cNvPr>
           <p:cNvPicPr>
             <a:picLocks noChangeAspect="1"/>
           </p:cNvPicPr>
@@ -13787,8 +14176,8 @@
         </p:blipFill>
         <p:spPr>
           <a:xfrm>
-            <a:off x="0" y="658368"/>
-            <a:ext cx="2468880" cy="5833872"/>
+            <a:off x="5349240" y="2461422"/>
+            <a:ext cx="6659575" cy="2913564"/>
           </a:xfrm>
           <a:prstGeom prst="rect">
             <a:avLst/>
@@ -13797,14 +14186,14 @@
       </p:pic>
       <p:sp>
         <p:nvSpPr>
-          <p:cNvPr id="4" name="Text 1"/>
+          <p:cNvPr id="6" name="Text 3"/>
           <p:cNvSpPr/>
           <p:nvPr/>
         </p:nvSpPr>
         <p:spPr>
           <a:xfrm>
-            <a:off x="2697480" y="1005840"/>
-            <a:ext cx="9174175" cy="731520"/>
+            <a:off x="5349240" y="6089904"/>
+            <a:ext cx="6659575" cy="347472"/>
           </a:xfrm>
           <a:prstGeom prst="rect">
             <a:avLst/>
@@ -13813,142 +14202,24 @@
           <a:ln/>
         </p:spPr>
         <p:txBody>
-          <a:bodyPr wrap="square" lIns="0" tIns="0" rIns="0" bIns="0" rtlCol="0" anchor="ctr">
-            <a:normAutofit/>
-          </a:bodyPr>
+          <a:bodyPr wrap="square" lIns="0" tIns="0" rIns="0" bIns="0" rtlCol="0" anchor="ctr"/>
           <a:lstStyle/>
           <a:p>
             <a:pPr algn="ctr" indent="0" marL="0">
               <a:buNone/>
             </a:pPr>
             <a:r>
-              <a:rPr lang="en-US" sz="3600" b="1" dirty="0">
-                <a:solidFill>
-                  <a:srgbClr val="990011"/>
+              <a:rPr lang="en-US" sz="1600" i="1" dirty="0">
+                <a:solidFill>
+                  <a:srgbClr val="555555"/>
                 </a:solidFill>
                 <a:latin typeface="Times New Roman" pitchFamily="34" charset="0"/>
                 <a:ea typeface="Times New Roman" pitchFamily="34" charset="-122"/>
                 <a:cs typeface="Times New Roman" pitchFamily="34" charset="-120"/>
               </a:rPr>
-              <a:t>2. Factors of Population Growth</a:t>
-            </a:r>
-            <a:endParaRPr lang="en-US" sz="3600" dirty="0"/>
-          </a:p>
-        </p:txBody>
-      </p:sp>
-      <p:sp>
-        <p:nvSpPr>
-          <p:cNvPr id="5" name="Text 2"/>
-          <p:cNvSpPr/>
-          <p:nvPr/>
-        </p:nvSpPr>
-        <p:spPr>
-          <a:xfrm>
-            <a:off x="2697480" y="1783080"/>
-            <a:ext cx="9174175" cy="4663440"/>
-          </a:xfrm>
-          <a:prstGeom prst="rect">
-            <a:avLst/>
-          </a:prstGeom>
-          <a:noFill/>
-          <a:ln/>
-        </p:spPr>
-        <p:txBody>
-          <a:bodyPr wrap="square" lIns="0" tIns="0" rIns="0" bIns="0" rtlCol="0" anchor="t"/>
-          <a:lstStyle/>
-          <a:p>
-            <a:pPr algn="l" indent="0" marL="0">
-              <a:spcAft>
-                <a:spcPts val="800"/>
-              </a:spcAft>
-              <a:buNone/>
-            </a:pPr>
-            <a:r>
-              <a:rPr lang="en-US" sz="4000" i="1" dirty="0">
-                <a:solidFill>
-                  <a:srgbClr val="111111"/>
-                </a:solidFill>
-                <a:latin typeface="Times New Roman" pitchFamily="34" charset="0"/>
-                <a:ea typeface="Times New Roman" pitchFamily="34" charset="-122"/>
-                <a:cs typeface="Times New Roman" pitchFamily="34" charset="-120"/>
-              </a:rPr>
-              <a:t>The population grows for the following reasons:</a:t>
-            </a:r>
-            <a:endParaRPr lang="en-US" sz="4000" dirty="0"/>
-          </a:p>
-          <a:p>
-            <a:pPr algn="l" indent="0" marL="0">
-              <a:spcAft>
-                <a:spcPts val="800"/>
-              </a:spcAft>
-              <a:buNone/>
-            </a:pPr>
-            <a:r>
-              <a:rPr lang="en-US" sz="4000" b="1" dirty="0">
-                <a:solidFill>
-                  <a:srgbClr val="111111"/>
-                </a:solidFill>
-                <a:latin typeface="Times New Roman" pitchFamily="34" charset="0"/>
-                <a:ea typeface="Times New Roman" pitchFamily="34" charset="-122"/>
-                <a:cs typeface="Times New Roman" pitchFamily="34" charset="-120"/>
-              </a:rPr>
-              <a:t>High birth rate: </a:t>
-            </a:r>
-            <a:pPr algn="l" indent="0" marL="0">
-              <a:spcAft>
-                <a:spcPts val="800"/>
-              </a:spcAft>
-              <a:buNone/>
-            </a:pPr>
-            <a:r>
-              <a:rPr lang="en-US" sz="4000" dirty="0">
-                <a:solidFill>
-                  <a:srgbClr val="111111"/>
-                </a:solidFill>
-                <a:latin typeface="Times New Roman" pitchFamily="34" charset="0"/>
-                <a:ea typeface="Times New Roman" pitchFamily="34" charset="-122"/>
-                <a:cs typeface="Times New Roman" pitchFamily="34" charset="-120"/>
-              </a:rPr>
-              <a:t>Many children are born, especially in poor countries.</a:t>
-            </a:r>
-            <a:endParaRPr lang="en-US" sz="4000" dirty="0"/>
-          </a:p>
-          <a:p>
-            <a:pPr algn="l" indent="0" marL="0">
-              <a:spcAft>
-                <a:spcPts val="800"/>
-              </a:spcAft>
-              <a:buNone/>
-            </a:pPr>
-            <a:r>
-              <a:rPr lang="en-US" sz="4000" b="1" dirty="0">
-                <a:solidFill>
-                  <a:srgbClr val="111111"/>
-                </a:solidFill>
-                <a:latin typeface="Times New Roman" pitchFamily="34" charset="0"/>
-                <a:ea typeface="Times New Roman" pitchFamily="34" charset="-122"/>
-                <a:cs typeface="Times New Roman" pitchFamily="34" charset="-120"/>
-              </a:rPr>
-              <a:t>Falling death rate: </a:t>
-            </a:r>
-            <a:pPr algn="l" indent="0" marL="0">
-              <a:spcAft>
-                <a:spcPts val="800"/>
-              </a:spcAft>
-              <a:buNone/>
-            </a:pPr>
-            <a:r>
-              <a:rPr lang="en-US" sz="4000" dirty="0">
-                <a:solidFill>
-                  <a:srgbClr val="111111"/>
-                </a:solidFill>
-                <a:latin typeface="Times New Roman" pitchFamily="34" charset="0"/>
-                <a:ea typeface="Times New Roman" pitchFamily="34" charset="-122"/>
-                <a:cs typeface="Times New Roman" pitchFamily="34" charset="-120"/>
-              </a:rPr>
-              <a:t>Vaccines, hospitals and clean water reduce deaths.</a:t>
-            </a:r>
-            <a:endParaRPr lang="en-US" sz="4000" dirty="0"/>
+              <a:t>Illustration: world population growth</a:t>
+            </a:r>
+            <a:endParaRPr lang="en-US" sz="1600" dirty="0"/>
           </a:p>
         </p:txBody>
       </p:sp>
@@ -14064,9 +14335,129 @@
           </a:p>
         </p:txBody>
       </p:sp>
+      <p:sp>
+        <p:nvSpPr>
+          <p:cNvPr id="3" name="Text 1"/>
+          <p:cNvSpPr/>
+          <p:nvPr/>
+        </p:nvSpPr>
+        <p:spPr>
+          <a:xfrm>
+            <a:off x="365760" y="1005840"/>
+            <a:ext cx="11460175" cy="731520"/>
+          </a:xfrm>
+          <a:prstGeom prst="rect">
+            <a:avLst/>
+          </a:prstGeom>
+          <a:noFill/>
+          <a:ln/>
+        </p:spPr>
+        <p:txBody>
+          <a:bodyPr wrap="square" lIns="0" tIns="0" rIns="0" bIns="0" rtlCol="0" anchor="ctr">
+            <a:normAutofit/>
+          </a:bodyPr>
+          <a:lstStyle/>
+          <a:p>
+            <a:pPr algn="ctr" indent="0" marL="0">
+              <a:buNone/>
+            </a:pPr>
+            <a:r>
+              <a:rPr lang="en-US" sz="3600" b="1" dirty="0">
+                <a:solidFill>
+                  <a:srgbClr val="990011"/>
+                </a:solidFill>
+                <a:latin typeface="Times New Roman" pitchFamily="34" charset="0"/>
+                <a:ea typeface="Times New Roman" pitchFamily="34" charset="-122"/>
+                <a:cs typeface="Times New Roman" pitchFamily="34" charset="-120"/>
+              </a:rPr>
+              <a:t>2. Factors of the Population Growth</a:t>
+            </a:r>
+            <a:endParaRPr lang="en-US" sz="3600" dirty="0"/>
+          </a:p>
+        </p:txBody>
+      </p:sp>
+      <p:sp>
+        <p:nvSpPr>
+          <p:cNvPr id="4" name="Text 2"/>
+          <p:cNvSpPr/>
+          <p:nvPr/>
+        </p:nvSpPr>
+        <p:spPr>
+          <a:xfrm>
+            <a:off x="365760" y="1783080"/>
+            <a:ext cx="4846320" cy="4617720"/>
+          </a:xfrm>
+          <a:prstGeom prst="rect">
+            <a:avLst/>
+          </a:prstGeom>
+          <a:noFill/>
+          <a:ln/>
+        </p:spPr>
+        <p:txBody>
+          <a:bodyPr wrap="square" lIns="0" tIns="0" rIns="0" bIns="0" rtlCol="0" anchor="t"/>
+          <a:lstStyle/>
+          <a:p>
+            <a:pPr algn="l" indent="0" marL="0">
+              <a:spcAft>
+                <a:spcPts val="800"/>
+              </a:spcAft>
+              <a:buNone/>
+            </a:pPr>
+            <a:r>
+              <a:rPr lang="en-US" sz="3600" i="1" dirty="0">
+                <a:solidFill>
+                  <a:srgbClr val="111111"/>
+                </a:solidFill>
+                <a:latin typeface="Times New Roman" pitchFamily="34" charset="0"/>
+                <a:ea typeface="Times New Roman" pitchFamily="34" charset="-122"/>
+                <a:cs typeface="Times New Roman" pitchFamily="34" charset="-120"/>
+              </a:rPr>
+              <a:t>The population grows for the following reasons:</a:t>
+            </a:r>
+            <a:endParaRPr lang="en-US" sz="3600" dirty="0"/>
+          </a:p>
+          <a:p>
+            <a:pPr algn="l" indent="0" marL="0">
+              <a:spcAft>
+                <a:spcPts val="800"/>
+              </a:spcAft>
+              <a:buNone/>
+            </a:pPr>
+            <a:r>
+              <a:rPr lang="en-US" sz="3600" b="1" dirty="0">
+                <a:solidFill>
+                  <a:srgbClr val="111111"/>
+                </a:solidFill>
+                <a:latin typeface="Times New Roman" pitchFamily="34" charset="0"/>
+                <a:ea typeface="Times New Roman" pitchFamily="34" charset="-122"/>
+                <a:cs typeface="Times New Roman" pitchFamily="34" charset="-120"/>
+              </a:rPr>
+              <a:t>High birth rate: </a:t>
+            </a:r>
+            <a:pPr algn="l" indent="0" marL="0">
+              <a:spcAft>
+                <a:spcPts val="800"/>
+              </a:spcAft>
+              <a:buNone/>
+            </a:pPr>
+            <a:r>
+              <a:rPr lang="en-US" sz="3600" dirty="0">
+                <a:solidFill>
+                  <a:srgbClr val="111111"/>
+                </a:solidFill>
+                <a:latin typeface="Times New Roman" pitchFamily="34" charset="0"/>
+                <a:ea typeface="Times New Roman" pitchFamily="34" charset="-122"/>
+                <a:cs typeface="Times New Roman" pitchFamily="34" charset="-120"/>
+              </a:rPr>
+              <a:t>Many children are born, especially in poor countries.</a:t>
+            </a:r>
+            <a:endParaRPr lang="en-US" sz="3600" dirty="0"/>
+          </a:p>
+        </p:txBody>
+      </p:sp>
       <p:pic>
         <p:nvPicPr>
-          <p:cNvPr id="3" name="Image 0" descr="/home/claude/f4/img/minesec_sheet.png">    </p:cNvPr>
+          <p:cNvPr id="5" name="Image 0" descr="/home/claude/f4/img/v2/usa_children.jpg">    </p:cNvPr>
           <p:cNvPicPr>
             <a:picLocks noChangeAspect="1"/>
           </p:cNvPicPr>
@@ -14080,8 +14471,8 @@
         </p:blipFill>
         <p:spPr>
           <a:xfrm>
-            <a:off x="0" y="658368"/>
-            <a:ext cx="5120640" cy="5833872"/>
+            <a:off x="5349240" y="2071212"/>
+            <a:ext cx="6659575" cy="3693983"/>
           </a:xfrm>
           <a:prstGeom prst="rect">
             <a:avLst/>
@@ -14090,14 +14481,14 @@
       </p:pic>
       <p:sp>
         <p:nvSpPr>
-          <p:cNvPr id="4" name="Text 1"/>
+          <p:cNvPr id="6" name="Text 3"/>
           <p:cNvSpPr/>
           <p:nvPr/>
         </p:nvSpPr>
         <p:spPr>
           <a:xfrm>
-            <a:off x="5349240" y="1005840"/>
-            <a:ext cx="6522415" cy="731520"/>
+            <a:off x="5349240" y="6089904"/>
+            <a:ext cx="6659575" cy="347472"/>
           </a:xfrm>
           <a:prstGeom prst="rect">
             <a:avLst/>
@@ -14106,85 +14497,24 @@
           <a:ln/>
         </p:spPr>
         <p:txBody>
-          <a:bodyPr wrap="square" lIns="0" tIns="0" rIns="0" bIns="0" rtlCol="0" anchor="ctr">
-            <a:normAutofit/>
-          </a:bodyPr>
+          <a:bodyPr wrap="square" lIns="0" tIns="0" rIns="0" bIns="0" rtlCol="0" anchor="ctr"/>
           <a:lstStyle/>
           <a:p>
             <a:pPr algn="ctr" indent="0" marL="0">
               <a:buNone/>
             </a:pPr>
             <a:r>
-              <a:rPr lang="en-US" sz="3600" b="1" dirty="0">
-                <a:solidFill>
-                  <a:srgbClr val="990011"/>
+              <a:rPr lang="en-US" sz="1600" i="1" dirty="0">
+                <a:solidFill>
+                  <a:srgbClr val="555555"/>
                 </a:solidFill>
                 <a:latin typeface="Times New Roman" pitchFamily="34" charset="0"/>
                 <a:ea typeface="Times New Roman" pitchFamily="34" charset="-122"/>
                 <a:cs typeface="Times New Roman" pitchFamily="34" charset="-120"/>
               </a:rPr>
-              <a:t>2. Factors of Population Growth (continued)</a:t>
-            </a:r>
-            <a:endParaRPr lang="en-US" sz="3600" dirty="0"/>
-          </a:p>
-        </p:txBody>
-      </p:sp>
-      <p:sp>
-        <p:nvSpPr>
-          <p:cNvPr id="5" name="Text 2"/>
-          <p:cNvSpPr/>
-          <p:nvPr/>
-        </p:nvSpPr>
-        <p:spPr>
-          <a:xfrm>
-            <a:off x="5349240" y="1783080"/>
-            <a:ext cx="6522415" cy="4663440"/>
-          </a:xfrm>
-          <a:prstGeom prst="rect">
-            <a:avLst/>
-          </a:prstGeom>
-          <a:noFill/>
-          <a:ln/>
-        </p:spPr>
-        <p:txBody>
-          <a:bodyPr wrap="square" lIns="0" tIns="0" rIns="0" bIns="0" rtlCol="0" anchor="t"/>
-          <a:lstStyle/>
-          <a:p>
-            <a:pPr algn="l" indent="0" marL="0">
-              <a:spcAft>
-                <a:spcPts val="800"/>
-              </a:spcAft>
-              <a:buNone/>
-            </a:pPr>
-            <a:r>
-              <a:rPr lang="en-US" sz="4000" b="1" dirty="0">
-                <a:solidFill>
-                  <a:srgbClr val="111111"/>
-                </a:solidFill>
-                <a:latin typeface="Times New Roman" pitchFamily="34" charset="0"/>
-                <a:ea typeface="Times New Roman" pitchFamily="34" charset="-122"/>
-                <a:cs typeface="Times New Roman" pitchFamily="34" charset="-120"/>
-              </a:rPr>
-              <a:t>Better food supply: </a:t>
-            </a:r>
-            <a:pPr algn="l" indent="0" marL="0">
-              <a:spcAft>
-                <a:spcPts val="800"/>
-              </a:spcAft>
-              <a:buNone/>
-            </a:pPr>
-            <a:r>
-              <a:rPr lang="en-US" sz="4000" dirty="0">
-                <a:solidFill>
-                  <a:srgbClr val="111111"/>
-                </a:solidFill>
-                <a:latin typeface="Times New Roman" pitchFamily="34" charset="0"/>
-                <a:ea typeface="Times New Roman" pitchFamily="34" charset="-122"/>
-                <a:cs typeface="Times New Roman" pitchFamily="34" charset="-120"/>
-              </a:rPr>
-              <a:t>More food allows more people to survive.</a:t>
-            </a:r>
-            <a:endParaRPr lang="en-US" sz="4000" dirty="0"/>
+              <a:t>Illustration: children</a:t>
+            </a:r>
+            <a:endParaRPr lang="en-US" sz="1600" dirty="0"/>
           </a:p>
         </p:txBody>
       </p:sp>
@@ -14300,9 +14630,109 @@
           </a:p>
         </p:txBody>
       </p:sp>
+      <p:sp>
+        <p:nvSpPr>
+          <p:cNvPr id="3" name="Text 1"/>
+          <p:cNvSpPr/>
+          <p:nvPr/>
+        </p:nvSpPr>
+        <p:spPr>
+          <a:xfrm>
+            <a:off x="365760" y="1005840"/>
+            <a:ext cx="11460175" cy="731520"/>
+          </a:xfrm>
+          <a:prstGeom prst="rect">
+            <a:avLst/>
+          </a:prstGeom>
+          <a:noFill/>
+          <a:ln/>
+        </p:spPr>
+        <p:txBody>
+          <a:bodyPr wrap="square" lIns="0" tIns="0" rIns="0" bIns="0" rtlCol="0" anchor="ctr">
+            <a:normAutofit/>
+          </a:bodyPr>
+          <a:lstStyle/>
+          <a:p>
+            <a:pPr algn="ctr" indent="0" marL="0">
+              <a:buNone/>
+            </a:pPr>
+            <a:r>
+              <a:rPr lang="en-US" sz="3600" b="1" dirty="0">
+                <a:solidFill>
+                  <a:srgbClr val="990011"/>
+                </a:solidFill>
+                <a:latin typeface="Times New Roman" pitchFamily="34" charset="0"/>
+                <a:ea typeface="Times New Roman" pitchFamily="34" charset="-122"/>
+                <a:cs typeface="Times New Roman" pitchFamily="34" charset="-120"/>
+              </a:rPr>
+              <a:t>2. Factors of the Population Growth</a:t>
+            </a:r>
+            <a:endParaRPr lang="en-US" sz="3600" dirty="0"/>
+          </a:p>
+        </p:txBody>
+      </p:sp>
+      <p:sp>
+        <p:nvSpPr>
+          <p:cNvPr id="4" name="Text 2"/>
+          <p:cNvSpPr/>
+          <p:nvPr/>
+        </p:nvSpPr>
+        <p:spPr>
+          <a:xfrm>
+            <a:off x="365760" y="1783080"/>
+            <a:ext cx="4846320" cy="4617720"/>
+          </a:xfrm>
+          <a:prstGeom prst="rect">
+            <a:avLst/>
+          </a:prstGeom>
+          <a:noFill/>
+          <a:ln/>
+        </p:spPr>
+        <p:txBody>
+          <a:bodyPr wrap="square" lIns="0" tIns="0" rIns="0" bIns="0" rtlCol="0" anchor="t"/>
+          <a:lstStyle/>
+          <a:p>
+            <a:pPr algn="l" indent="0" marL="0">
+              <a:spcAft>
+                <a:spcPts val="800"/>
+              </a:spcAft>
+              <a:buNone/>
+            </a:pPr>
+            <a:r>
+              <a:rPr lang="en-US" sz="3600" b="1" dirty="0">
+                <a:solidFill>
+                  <a:srgbClr val="111111"/>
+                </a:solidFill>
+                <a:latin typeface="Times New Roman" pitchFamily="34" charset="0"/>
+                <a:ea typeface="Times New Roman" pitchFamily="34" charset="-122"/>
+                <a:cs typeface="Times New Roman" pitchFamily="34" charset="-120"/>
+              </a:rPr>
+              <a:t>Falling death rate: </a:t>
+            </a:r>
+            <a:pPr algn="l" indent="0" marL="0">
+              <a:spcAft>
+                <a:spcPts val="800"/>
+              </a:spcAft>
+              <a:buNone/>
+            </a:pPr>
+            <a:r>
+              <a:rPr lang="en-US" sz="3600" dirty="0">
+                <a:solidFill>
+                  <a:srgbClr val="111111"/>
+                </a:solidFill>
+                <a:latin typeface="Times New Roman" pitchFamily="34" charset="0"/>
+                <a:ea typeface="Times New Roman" pitchFamily="34" charset="-122"/>
+                <a:cs typeface="Times New Roman" pitchFamily="34" charset="-120"/>
+              </a:rPr>
+              <a:t>Vaccines, hospitals and clean water reduce deaths.</a:t>
+            </a:r>
+            <a:endParaRPr lang="en-US" sz="3600" dirty="0"/>
+          </a:p>
+        </p:txBody>
+      </p:sp>
       <p:pic>
         <p:nvPicPr>
-          <p:cNvPr id="3" name="Image 0" descr="/home/claude/f4/img/minesec_sheet.png">    </p:cNvPr>
+          <p:cNvPr id="5" name="Image 0" descr="/home/claude/f4/img/v2/usa_vaccine.jpg">    </p:cNvPr>
           <p:cNvPicPr>
             <a:picLocks noChangeAspect="1"/>
           </p:cNvPicPr>
@@ -14316,8 +14746,8 @@
         </p:blipFill>
         <p:spPr>
           <a:xfrm>
-            <a:off x="0" y="658368"/>
-            <a:ext cx="3840480" cy="5833872"/>
+            <a:off x="5349240" y="2071212"/>
+            <a:ext cx="6659575" cy="3693983"/>
           </a:xfrm>
           <a:prstGeom prst="rect">
             <a:avLst/>
@@ -14326,14 +14756,14 @@
       </p:pic>
       <p:sp>
         <p:nvSpPr>
-          <p:cNvPr id="4" name="Text 1"/>
+          <p:cNvPr id="6" name="Text 3"/>
           <p:cNvSpPr/>
           <p:nvPr/>
         </p:nvSpPr>
         <p:spPr>
           <a:xfrm>
-            <a:off x="4069080" y="1005840"/>
-            <a:ext cx="7802575" cy="731520"/>
+            <a:off x="5349240" y="6089904"/>
+            <a:ext cx="6659575" cy="347472"/>
           </a:xfrm>
           <a:prstGeom prst="rect">
             <a:avLst/>
@@ -14342,142 +14772,24 @@
           <a:ln/>
         </p:spPr>
         <p:txBody>
-          <a:bodyPr wrap="square" lIns="0" tIns="0" rIns="0" bIns="0" rtlCol="0" anchor="ctr">
-            <a:normAutofit/>
-          </a:bodyPr>
+          <a:bodyPr wrap="square" lIns="0" tIns="0" rIns="0" bIns="0" rtlCol="0" anchor="ctr"/>
           <a:lstStyle/>
           <a:p>
             <a:pPr algn="ctr" indent="0" marL="0">
               <a:buNone/>
             </a:pPr>
             <a:r>
-              <a:rPr lang="en-US" sz="3600" b="1" dirty="0">
-                <a:solidFill>
-                  <a:srgbClr val="990011"/>
+              <a:rPr lang="en-US" sz="1600" i="1" dirty="0">
+                <a:solidFill>
+                  <a:srgbClr val="555555"/>
                 </a:solidFill>
                 <a:latin typeface="Times New Roman" pitchFamily="34" charset="0"/>
                 <a:ea typeface="Times New Roman" pitchFamily="34" charset="-122"/>
                 <a:cs typeface="Times New Roman" pitchFamily="34" charset="-120"/>
               </a:rPr>
-              <a:t>3. Implications on Natural Resources</a:t>
-            </a:r>
-            <a:endParaRPr lang="en-US" sz="3600" dirty="0"/>
-          </a:p>
-        </p:txBody>
-      </p:sp>
-      <p:sp>
-        <p:nvSpPr>
-          <p:cNvPr id="5" name="Text 2"/>
-          <p:cNvSpPr/>
-          <p:nvPr/>
-        </p:nvSpPr>
-        <p:spPr>
-          <a:xfrm>
-            <a:off x="4069080" y="1783080"/>
-            <a:ext cx="7802575" cy="4663440"/>
-          </a:xfrm>
-          <a:prstGeom prst="rect">
-            <a:avLst/>
-          </a:prstGeom>
-          <a:noFill/>
-          <a:ln/>
-        </p:spPr>
-        <p:txBody>
-          <a:bodyPr wrap="square" lIns="0" tIns="0" rIns="0" bIns="0" rtlCol="0" anchor="t"/>
-          <a:lstStyle/>
-          <a:p>
-            <a:pPr algn="l" indent="0" marL="0">
-              <a:spcAft>
-                <a:spcPts val="800"/>
-              </a:spcAft>
-              <a:buNone/>
-            </a:pPr>
-            <a:r>
-              <a:rPr lang="en-US" sz="4000" i="1" dirty="0">
-                <a:solidFill>
-                  <a:srgbClr val="111111"/>
-                </a:solidFill>
-                <a:latin typeface="Times New Roman" pitchFamily="34" charset="0"/>
-                <a:ea typeface="Times New Roman" pitchFamily="34" charset="-122"/>
-                <a:cs typeface="Times New Roman" pitchFamily="34" charset="-120"/>
-              </a:rPr>
-              <a:t>Rapid growth has the following effects on resources:</a:t>
-            </a:r>
-            <a:endParaRPr lang="en-US" sz="4000" dirty="0"/>
-          </a:p>
-          <a:p>
-            <a:pPr algn="l" indent="0" marL="0">
-              <a:spcAft>
-                <a:spcPts val="800"/>
-              </a:spcAft>
-              <a:buNone/>
-            </a:pPr>
-            <a:r>
-              <a:rPr lang="en-US" sz="4000" b="1" dirty="0">
-                <a:solidFill>
-                  <a:srgbClr val="111111"/>
-                </a:solidFill>
-                <a:latin typeface="Times New Roman" pitchFamily="34" charset="0"/>
-                <a:ea typeface="Times New Roman" pitchFamily="34" charset="-122"/>
-                <a:cs typeface="Times New Roman" pitchFamily="34" charset="-120"/>
-              </a:rPr>
-              <a:t>Land: </a:t>
-            </a:r>
-            <a:pPr algn="l" indent="0" marL="0">
-              <a:spcAft>
-                <a:spcPts val="800"/>
-              </a:spcAft>
-              <a:buNone/>
-            </a:pPr>
-            <a:r>
-              <a:rPr lang="en-US" sz="4000" dirty="0">
-                <a:solidFill>
-                  <a:srgbClr val="111111"/>
-                </a:solidFill>
-                <a:latin typeface="Times New Roman" pitchFamily="34" charset="0"/>
-                <a:ea typeface="Times New Roman" pitchFamily="34" charset="-122"/>
-                <a:cs typeface="Times New Roman" pitchFamily="34" charset="-120"/>
-              </a:rPr>
-              <a:t>Farmland becomes scarce and farms become smaller.</a:t>
-            </a:r>
-            <a:endParaRPr lang="en-US" sz="4000" dirty="0"/>
-          </a:p>
-          <a:p>
-            <a:pPr algn="l" indent="0" marL="0">
-              <a:spcAft>
-                <a:spcPts val="800"/>
-              </a:spcAft>
-              <a:buNone/>
-            </a:pPr>
-            <a:r>
-              <a:rPr lang="en-US" sz="4000" b="1" dirty="0">
-                <a:solidFill>
-                  <a:srgbClr val="111111"/>
-                </a:solidFill>
-                <a:latin typeface="Times New Roman" pitchFamily="34" charset="0"/>
-                <a:ea typeface="Times New Roman" pitchFamily="34" charset="-122"/>
-                <a:cs typeface="Times New Roman" pitchFamily="34" charset="-120"/>
-              </a:rPr>
-              <a:t>Forests: </a:t>
-            </a:r>
-            <a:pPr algn="l" indent="0" marL="0">
-              <a:spcAft>
-                <a:spcPts val="800"/>
-              </a:spcAft>
-              <a:buNone/>
-            </a:pPr>
-            <a:r>
-              <a:rPr lang="en-US" sz="4000" dirty="0">
-                <a:solidFill>
-                  <a:srgbClr val="111111"/>
-                </a:solidFill>
-                <a:latin typeface="Times New Roman" pitchFamily="34" charset="0"/>
-                <a:ea typeface="Times New Roman" pitchFamily="34" charset="-122"/>
-                <a:cs typeface="Times New Roman" pitchFamily="34" charset="-120"/>
-              </a:rPr>
-              <a:t>Forests are cut for farms, firewood and building.</a:t>
-            </a:r>
-            <a:endParaRPr lang="en-US" sz="4000" dirty="0"/>
+              <a:t>Illustration: a vaccination</a:t>
+            </a:r>
+            <a:endParaRPr lang="en-US" sz="1600" dirty="0"/>
           </a:p>
         </p:txBody>
       </p:sp>
@@ -14652,7 +14964,7 @@
                 <a:ea typeface="Times New Roman" pitchFamily="34" charset="-122"/>
                 <a:cs typeface="Times New Roman" pitchFamily="34" charset="-120"/>
               </a:rPr>
-              <a:t>3. Implications on Natural Resources (continued)</a:t>
+              <a:t>2. Factors of the Population Growth</a:t>
             </a:r>
             <a:endParaRPr lang="en-US" sz="3600" dirty="0"/>
           </a:p>
@@ -14694,7 +15006,7 @@
                 <a:ea typeface="Times New Roman" pitchFamily="34" charset="-122"/>
                 <a:cs typeface="Times New Roman" pitchFamily="34" charset="-120"/>
               </a:rPr>
-              <a:t>Water: </a:t>
+              <a:t>Better food supply: </a:t>
             </a:r>
             <a:pPr algn="l" indent="0" marL="0">
               <a:spcAft>
@@ -14711,7 +15023,44 @@
                 <a:ea typeface="Times New Roman" pitchFamily="34" charset="-122"/>
                 <a:cs typeface="Times New Roman" pitchFamily="34" charset="-120"/>
               </a:rPr>
-              <a:t>Clean water becomes scarce and polluted.</a:t>
+              <a:t>More food allows more people to survive.</a:t>
+            </a:r>
+            <a:endParaRPr lang="en-US" sz="4000" dirty="0"/>
+          </a:p>
+          <a:p>
+            <a:pPr algn="l" indent="0" marL="0">
+              <a:spcAft>
+                <a:spcPts val="800"/>
+              </a:spcAft>
+              <a:buNone/>
+            </a:pPr>
+            <a:r>
+              <a:rPr lang="en-US" sz="4000" b="1" dirty="0">
+                <a:solidFill>
+                  <a:srgbClr val="111111"/>
+                </a:solidFill>
+                <a:latin typeface="Times New Roman" pitchFamily="34" charset="0"/>
+                <a:ea typeface="Times New Roman" pitchFamily="34" charset="-122"/>
+                <a:cs typeface="Times New Roman" pitchFamily="34" charset="-120"/>
+              </a:rPr>
+              <a:t>Early marriages and big families: </a:t>
+            </a:r>
+            <a:pPr algn="l" indent="0" marL="0">
+              <a:spcAft>
+                <a:spcPts val="800"/>
+              </a:spcAft>
+              <a:buNone/>
+            </a:pPr>
+            <a:r>
+              <a:rPr lang="en-US" sz="4000" dirty="0">
+                <a:solidFill>
+                  <a:srgbClr val="111111"/>
+                </a:solidFill>
+                <a:latin typeface="Times New Roman" pitchFamily="34" charset="0"/>
+                <a:ea typeface="Times New Roman" pitchFamily="34" charset="-122"/>
+                <a:cs typeface="Times New Roman" pitchFamily="34" charset="-120"/>
+              </a:rPr>
+              <a:t>In many places people marry young and want many children.</a:t>
             </a:r>
             <a:endParaRPr lang="en-US" sz="4000" dirty="0"/>
           </a:p>
@@ -15132,7 +15481,7 @@
                 <a:ea typeface="Calibri" pitchFamily="34" charset="-122"/>
                 <a:cs typeface="Calibri" pitchFamily="34" charset="-120"/>
               </a:rPr>
-              <a:t>FORMATIVE EVALUATION</a:t>
+              <a:t>BOARD SUMMARY</a:t>
             </a:r>
             <a:endParaRPr lang="en-US" sz="1400" dirty="0"/>
           </a:p>
@@ -15197,7 +15546,7 @@
                 <a:ea typeface="Times New Roman" pitchFamily="34" charset="-122"/>
                 <a:cs typeface="Times New Roman" pitchFamily="34" charset="-120"/>
               </a:rPr>
-              <a:t>Evaluation 1</a:t>
+              <a:t>3. Implications on Natural Resources</a:t>
             </a:r>
             <a:endParaRPr lang="en-US" sz="3600" dirty="0"/>
           </a:p>
@@ -15231,7 +15580,7 @@
               <a:buNone/>
             </a:pPr>
             <a:r>
-              <a:rPr lang="en-US" sz="4000" dirty="0">
+              <a:rPr lang="en-US" sz="4000" i="1" dirty="0">
                 <a:solidFill>
                   <a:srgbClr val="111111"/>
                 </a:solidFill>
@@ -15239,7 +15588,44 @@
                 <a:ea typeface="Times New Roman" pitchFamily="34" charset="-122"/>
                 <a:cs typeface="Times New Roman" pitchFamily="34" charset="-120"/>
               </a:rPr>
-              <a:t>Give two factors of rapid population growth.</a:t>
+              <a:t>Rapid growth has the following effects on natural resources:</a:t>
+            </a:r>
+            <a:endParaRPr lang="en-US" sz="4000" dirty="0"/>
+          </a:p>
+          <a:p>
+            <a:pPr algn="l" indent="0" marL="0">
+              <a:spcAft>
+                <a:spcPts val="800"/>
+              </a:spcAft>
+              <a:buNone/>
+            </a:pPr>
+            <a:r>
+              <a:rPr lang="en-US" sz="4000" b="1" dirty="0">
+                <a:solidFill>
+                  <a:srgbClr val="111111"/>
+                </a:solidFill>
+                <a:latin typeface="Times New Roman" pitchFamily="34" charset="0"/>
+                <a:ea typeface="Times New Roman" pitchFamily="34" charset="-122"/>
+                <a:cs typeface="Times New Roman" pitchFamily="34" charset="-120"/>
+              </a:rPr>
+              <a:t>Land: </a:t>
+            </a:r>
+            <a:pPr algn="l" indent="0" marL="0">
+              <a:spcAft>
+                <a:spcPts val="800"/>
+              </a:spcAft>
+              <a:buNone/>
+            </a:pPr>
+            <a:r>
+              <a:rPr lang="en-US" sz="4000" dirty="0">
+                <a:solidFill>
+                  <a:srgbClr val="111111"/>
+                </a:solidFill>
+                <a:latin typeface="Times New Roman" pitchFamily="34" charset="0"/>
+                <a:ea typeface="Times New Roman" pitchFamily="34" charset="-122"/>
+                <a:cs typeface="Times New Roman" pitchFamily="34" charset="-120"/>
+              </a:rPr>
+              <a:t>Farmland becomes scarce, and farms become smaller.</a:t>
             </a:r>
             <a:endParaRPr lang="en-US" sz="4000" dirty="0"/>
           </a:p>
@@ -15351,15 +15737,115 @@
                 <a:ea typeface="Calibri" pitchFamily="34" charset="-122"/>
                 <a:cs typeface="Calibri" pitchFamily="34" charset="-120"/>
               </a:rPr>
-              <a:t>FORMATIVE EVALUATION</a:t>
+              <a:t>BOARD SUMMARY</a:t>
             </a:r>
             <a:endParaRPr lang="en-US" sz="1400" dirty="0"/>
+          </a:p>
+        </p:txBody>
+      </p:sp>
+      <p:sp>
+        <p:nvSpPr>
+          <p:cNvPr id="3" name="Text 1"/>
+          <p:cNvSpPr/>
+          <p:nvPr/>
+        </p:nvSpPr>
+        <p:spPr>
+          <a:xfrm>
+            <a:off x="365760" y="1005840"/>
+            <a:ext cx="11460175" cy="731520"/>
+          </a:xfrm>
+          <a:prstGeom prst="rect">
+            <a:avLst/>
+          </a:prstGeom>
+          <a:noFill/>
+          <a:ln/>
+        </p:spPr>
+        <p:txBody>
+          <a:bodyPr wrap="square" lIns="0" tIns="0" rIns="0" bIns="0" rtlCol="0" anchor="ctr">
+            <a:normAutofit/>
+          </a:bodyPr>
+          <a:lstStyle/>
+          <a:p>
+            <a:pPr algn="ctr" indent="0" marL="0">
+              <a:buNone/>
+            </a:pPr>
+            <a:r>
+              <a:rPr lang="en-US" sz="3600" b="1" dirty="0">
+                <a:solidFill>
+                  <a:srgbClr val="990011"/>
+                </a:solidFill>
+                <a:latin typeface="Times New Roman" pitchFamily="34" charset="0"/>
+                <a:ea typeface="Times New Roman" pitchFamily="34" charset="-122"/>
+                <a:cs typeface="Times New Roman" pitchFamily="34" charset="-120"/>
+              </a:rPr>
+              <a:t>3. Implications on Natural Resources</a:t>
+            </a:r>
+            <a:endParaRPr lang="en-US" sz="3600" dirty="0"/>
+          </a:p>
+        </p:txBody>
+      </p:sp>
+      <p:sp>
+        <p:nvSpPr>
+          <p:cNvPr id="4" name="Text 2"/>
+          <p:cNvSpPr/>
+          <p:nvPr/>
+        </p:nvSpPr>
+        <p:spPr>
+          <a:xfrm>
+            <a:off x="365760" y="1783080"/>
+            <a:ext cx="4846320" cy="4617720"/>
+          </a:xfrm>
+          <a:prstGeom prst="rect">
+            <a:avLst/>
+          </a:prstGeom>
+          <a:noFill/>
+          <a:ln/>
+        </p:spPr>
+        <p:txBody>
+          <a:bodyPr wrap="square" lIns="0" tIns="0" rIns="0" bIns="0" rtlCol="0" anchor="t"/>
+          <a:lstStyle/>
+          <a:p>
+            <a:pPr algn="l" indent="0" marL="0">
+              <a:spcAft>
+                <a:spcPts val="800"/>
+              </a:spcAft>
+              <a:buNone/>
+            </a:pPr>
+            <a:r>
+              <a:rPr lang="en-US" sz="3600" b="1" dirty="0">
+                <a:solidFill>
+                  <a:srgbClr val="111111"/>
+                </a:solidFill>
+                <a:latin typeface="Times New Roman" pitchFamily="34" charset="0"/>
+                <a:ea typeface="Times New Roman" pitchFamily="34" charset="-122"/>
+                <a:cs typeface="Times New Roman" pitchFamily="34" charset="-120"/>
+              </a:rPr>
+              <a:t>Forests: </a:t>
+            </a:r>
+            <a:pPr algn="l" indent="0" marL="0">
+              <a:spcAft>
+                <a:spcPts val="800"/>
+              </a:spcAft>
+              <a:buNone/>
+            </a:pPr>
+            <a:r>
+              <a:rPr lang="en-US" sz="3600" dirty="0">
+                <a:solidFill>
+                  <a:srgbClr val="111111"/>
+                </a:solidFill>
+                <a:latin typeface="Times New Roman" pitchFamily="34" charset="0"/>
+                <a:ea typeface="Times New Roman" pitchFamily="34" charset="-122"/>
+                <a:cs typeface="Times New Roman" pitchFamily="34" charset="-120"/>
+              </a:rPr>
+              <a:t>Forests are cut for farms, firewood and building.</a:t>
+            </a:r>
+            <a:endParaRPr lang="en-US" sz="3600" dirty="0"/>
           </a:p>
         </p:txBody>
       </p:sp>
       <p:pic>
         <p:nvPicPr>
-          <p:cNvPr id="3" name="Image 0" descr="/home/claude/f4/img/minesec_sheet.png">    </p:cNvPr>
+          <p:cNvPr id="5" name="Image 0" descr="/home/claude/f4/img/v2/f2t_clearing.jpg">    </p:cNvPr>
           <p:cNvPicPr>
             <a:picLocks noChangeAspect="1"/>
           </p:cNvPicPr>
@@ -15373,8 +15859,8 @@
         </p:blipFill>
         <p:spPr>
           <a:xfrm>
-            <a:off x="0" y="658368"/>
-            <a:ext cx="5120640" cy="5833872"/>
+            <a:off x="5349240" y="2071212"/>
+            <a:ext cx="6659575" cy="3693983"/>
           </a:xfrm>
           <a:prstGeom prst="rect">
             <a:avLst/>
@@ -15383,14 +15869,14 @@
       </p:pic>
       <p:sp>
         <p:nvSpPr>
-          <p:cNvPr id="4" name="Text 1"/>
+          <p:cNvPr id="6" name="Text 3"/>
           <p:cNvSpPr/>
           <p:nvPr/>
         </p:nvSpPr>
         <p:spPr>
           <a:xfrm>
-            <a:off x="5349240" y="1005840"/>
-            <a:ext cx="6522415" cy="731520"/>
+            <a:off x="5349240" y="6089904"/>
+            <a:ext cx="6659575" cy="347472"/>
           </a:xfrm>
           <a:prstGeom prst="rect">
             <a:avLst/>
@@ -15399,68 +15885,24 @@
           <a:ln/>
         </p:spPr>
         <p:txBody>
-          <a:bodyPr wrap="square" lIns="0" tIns="0" rIns="0" bIns="0" rtlCol="0" anchor="ctr">
-            <a:normAutofit/>
-          </a:bodyPr>
+          <a:bodyPr wrap="square" lIns="0" tIns="0" rIns="0" bIns="0" rtlCol="0" anchor="ctr"/>
           <a:lstStyle/>
           <a:p>
             <a:pPr algn="ctr" indent="0" marL="0">
               <a:buNone/>
             </a:pPr>
             <a:r>
-              <a:rPr lang="en-US" sz="3600" b="1" dirty="0">
-                <a:solidFill>
-                  <a:srgbClr val="990011"/>
+              <a:rPr lang="en-US" sz="1600" i="1" dirty="0">
+                <a:solidFill>
+                  <a:srgbClr val="555555"/>
                 </a:solidFill>
                 <a:latin typeface="Times New Roman" pitchFamily="34" charset="0"/>
                 <a:ea typeface="Times New Roman" pitchFamily="34" charset="-122"/>
                 <a:cs typeface="Times New Roman" pitchFamily="34" charset="-120"/>
               </a:rPr>
-              <a:t>Expected Answer</a:t>
-            </a:r>
-            <a:endParaRPr lang="en-US" sz="3600" dirty="0"/>
-          </a:p>
-        </p:txBody>
-      </p:sp>
-      <p:sp>
-        <p:nvSpPr>
-          <p:cNvPr id="5" name="Text 2"/>
-          <p:cNvSpPr/>
-          <p:nvPr/>
-        </p:nvSpPr>
-        <p:spPr>
-          <a:xfrm>
-            <a:off x="5349240" y="1783080"/>
-            <a:ext cx="6522415" cy="4663440"/>
-          </a:xfrm>
-          <a:prstGeom prst="rect">
-            <a:avLst/>
-          </a:prstGeom>
-          <a:noFill/>
-          <a:ln/>
-        </p:spPr>
-        <p:txBody>
-          <a:bodyPr wrap="square" lIns="0" tIns="0" rIns="0" bIns="0" rtlCol="0" anchor="t"/>
-          <a:lstStyle/>
-          <a:p>
-            <a:pPr algn="l" indent="0" marL="0">
-              <a:spcAft>
-                <a:spcPts val="800"/>
-              </a:spcAft>
-              <a:buNone/>
-            </a:pPr>
-            <a:r>
-              <a:rPr lang="en-US" sz="4000" dirty="0">
-                <a:solidFill>
-                  <a:srgbClr val="111111"/>
-                </a:solidFill>
-                <a:latin typeface="Times New Roman" pitchFamily="34" charset="0"/>
-                <a:ea typeface="Times New Roman" pitchFamily="34" charset="-122"/>
-                <a:cs typeface="Times New Roman" pitchFamily="34" charset="-120"/>
-              </a:rPr>
-              <a:t>A high birth rate and a falling death rate.</a:t>
-            </a:r>
-            <a:endParaRPr lang="en-US" sz="4000" dirty="0"/>
+              <a:t>Illustration: forest cleared for farms</a:t>
+            </a:r>
+            <a:endParaRPr lang="en-US" sz="1600" dirty="0"/>
           </a:p>
         </p:txBody>
       </p:sp>
@@ -15570,7 +16012,7 @@
                 <a:ea typeface="Calibri" pitchFamily="34" charset="-122"/>
                 <a:cs typeface="Calibri" pitchFamily="34" charset="-120"/>
               </a:rPr>
-              <a:t>FORMATIVE EVALUATION</a:t>
+              <a:t>BOARD SUMMARY</a:t>
             </a:r>
             <a:endParaRPr lang="en-US" sz="1400" dirty="0"/>
           </a:p>
@@ -15635,7 +16077,7 @@
                 <a:ea typeface="Times New Roman" pitchFamily="34" charset="-122"/>
                 <a:cs typeface="Times New Roman" pitchFamily="34" charset="-120"/>
               </a:rPr>
-              <a:t>Evaluation 2</a:t>
+              <a:t>3. Implications on Natural Resources</a:t>
             </a:r>
             <a:endParaRPr lang="en-US" sz="3600" dirty="0"/>
           </a:p>
@@ -15669,7 +16111,7 @@
               <a:buNone/>
             </a:pPr>
             <a:r>
-              <a:rPr lang="en-US" sz="4000" dirty="0">
+              <a:rPr lang="en-US" sz="4000" b="1" dirty="0">
                 <a:solidFill>
                   <a:srgbClr val="111111"/>
                 </a:solidFill>
@@ -15677,7 +16119,61 @@
                 <a:ea typeface="Times New Roman" pitchFamily="34" charset="-122"/>
                 <a:cs typeface="Times New Roman" pitchFamily="34" charset="-120"/>
               </a:rPr>
-              <a:t>Give two effects on natural resources.</a:t>
+              <a:t>Water: </a:t>
+            </a:r>
+            <a:pPr algn="l" indent="0" marL="0">
+              <a:spcAft>
+                <a:spcPts val="800"/>
+              </a:spcAft>
+              <a:buNone/>
+            </a:pPr>
+            <a:r>
+              <a:rPr lang="en-US" sz="4000" dirty="0">
+                <a:solidFill>
+                  <a:srgbClr val="111111"/>
+                </a:solidFill>
+                <a:latin typeface="Times New Roman" pitchFamily="34" charset="0"/>
+                <a:ea typeface="Times New Roman" pitchFamily="34" charset="-122"/>
+                <a:cs typeface="Times New Roman" pitchFamily="34" charset="-120"/>
+              </a:rPr>
+              <a:t>Clean water becomes scarce and polluted.</a:t>
+            </a:r>
+            <a:endParaRPr lang="en-US" sz="4000" dirty="0"/>
+          </a:p>
+          <a:p>
+            <a:pPr algn="l" indent="0" marL="0">
+              <a:spcAft>
+                <a:spcPts val="800"/>
+              </a:spcAft>
+              <a:buNone/>
+            </a:pPr>
+            <a:r>
+              <a:rPr lang="en-US" sz="4000" b="1" dirty="0">
+                <a:solidFill>
+                  <a:srgbClr val="111111"/>
+                </a:solidFill>
+                <a:latin typeface="Times New Roman" pitchFamily="34" charset="0"/>
+                <a:ea typeface="Times New Roman" pitchFamily="34" charset="-122"/>
+                <a:cs typeface="Times New Roman" pitchFamily="34" charset="-120"/>
+              </a:rPr>
+              <a:t>Soils: </a:t>
+            </a:r>
+            <a:pPr algn="l" indent="0" marL="0">
+              <a:spcAft>
+                <a:spcPts val="800"/>
+              </a:spcAft>
+              <a:buNone/>
+            </a:pPr>
+            <a:r>
+              <a:rPr lang="en-US" sz="4000" dirty="0">
+                <a:solidFill>
+                  <a:srgbClr val="111111"/>
+                </a:solidFill>
+                <a:latin typeface="Times New Roman" pitchFamily="34" charset="0"/>
+                <a:ea typeface="Times New Roman" pitchFamily="34" charset="-122"/>
+                <a:cs typeface="Times New Roman" pitchFamily="34" charset="-120"/>
+              </a:rPr>
+              <a:t>Soils are overused and lose their fertility.</a:t>
             </a:r>
             <a:endParaRPr lang="en-US" sz="4000" dirty="0"/>
           </a:p>
@@ -15854,7 +16350,7 @@
                 <a:ea typeface="Times New Roman" pitchFamily="34" charset="-122"/>
                 <a:cs typeface="Times New Roman" pitchFamily="34" charset="-120"/>
               </a:rPr>
-              <a:t>Expected Answer</a:t>
+              <a:t>Evaluation 1</a:t>
             </a:r>
             <a:endParaRPr lang="en-US" sz="3600" dirty="0"/>
           </a:p>
@@ -15896,7 +16392,7 @@
                 <a:ea typeface="Times New Roman" pitchFamily="34" charset="-122"/>
                 <a:cs typeface="Times New Roman" pitchFamily="34" charset="-120"/>
               </a:rPr>
-              <a:t>Deforestation and shortage of land.</a:t>
+              <a:t>Give two factors of rapid population growth.</a:t>
             </a:r>
             <a:endParaRPr lang="en-US" sz="4000" dirty="0"/>
           </a:p>
@@ -16008,7 +16504,7 @@
                 <a:ea typeface="Calibri" pitchFamily="34" charset="-122"/>
                 <a:cs typeface="Calibri" pitchFamily="34" charset="-120"/>
               </a:rPr>
-              <a:t>REMEDIATION</a:t>
+              <a:t>FORMATIVE EVALUATION</a:t>
             </a:r>
             <a:endParaRPr lang="en-US" sz="1400" dirty="0"/>
           </a:p>
@@ -16031,7 +16527,7 @@
         <p:spPr>
           <a:xfrm>
             <a:off x="0" y="658368"/>
-            <a:ext cx="3840480" cy="5833872"/>
+            <a:ext cx="5120640" cy="5833872"/>
           </a:xfrm>
           <a:prstGeom prst="rect">
             <a:avLst/>
@@ -16046,8 +16542,8 @@
         </p:nvSpPr>
         <p:spPr>
           <a:xfrm>
-            <a:off x="4069080" y="1005840"/>
-            <a:ext cx="7802575" cy="731520"/>
+            <a:off x="5349240" y="1005840"/>
+            <a:ext cx="6522415" cy="731520"/>
           </a:xfrm>
           <a:prstGeom prst="rect">
             <a:avLst/>
@@ -16073,7 +16569,7 @@
                 <a:ea typeface="Times New Roman" pitchFamily="34" charset="-122"/>
                 <a:cs typeface="Times New Roman" pitchFamily="34" charset="-120"/>
               </a:rPr>
-              <a:t>Remediation</a:t>
+              <a:t>Expected Answer</a:t>
             </a:r>
             <a:endParaRPr lang="en-US" sz="3600" dirty="0"/>
           </a:p>
@@ -16087,8 +16583,8 @@
         </p:nvSpPr>
         <p:spPr>
           <a:xfrm>
-            <a:off x="4069080" y="1783080"/>
-            <a:ext cx="7802575" cy="4663440"/>
+            <a:off x="5349240" y="1783080"/>
+            <a:ext cx="6522415" cy="4663440"/>
           </a:xfrm>
           <a:prstGeom prst="rect">
             <a:avLst/>
@@ -16107,7 +16603,7 @@
               <a:buNone/>
             </a:pPr>
             <a:r>
-              <a:rPr lang="en-US" sz="4000" b="1" dirty="0">
+              <a:rPr lang="en-US" sz="4000" dirty="0">
                 <a:solidFill>
                   <a:srgbClr val="111111"/>
                 </a:solidFill>
@@ -16115,73 +16611,7 @@
                 <a:ea typeface="Times New Roman" pitchFamily="34" charset="-122"/>
                 <a:cs typeface="Times New Roman" pitchFamily="34" charset="-120"/>
               </a:rPr>
-              <a:t>Fill in the blanks:</a:t>
-            </a:r>
-            <a:endParaRPr lang="en-US" sz="4000" dirty="0"/>
-          </a:p>
-          <a:p>
-            <a:pPr algn="l" marL="342900" indent="-342900">
-              <a:spcAft>
-                <a:spcPts val="800"/>
-              </a:spcAft>
-              <a:buSzPct val="100000"/>
-              <a:buFont typeface="+mj-lt"/>
-              <a:buAutoNum type="arabicPeriod" startAt="1"/>
-            </a:pPr>
-            <a:r>
-              <a:rPr lang="en-US" sz="4000" dirty="0">
-                <a:solidFill>
-                  <a:srgbClr val="111111"/>
-                </a:solidFill>
-                <a:latin typeface="Times New Roman" pitchFamily="34" charset="0"/>
-                <a:ea typeface="Times New Roman" pitchFamily="34" charset="-122"/>
-                <a:cs typeface="Times New Roman" pitchFamily="34" charset="-120"/>
-              </a:rPr>
-              <a:t>The world population reached ______ billion in 2022.</a:t>
-            </a:r>
-            <a:endParaRPr lang="en-US" sz="4000" dirty="0"/>
-          </a:p>
-          <a:p>
-            <a:pPr algn="l" marL="342900" indent="-342900">
-              <a:spcAft>
-                <a:spcPts val="800"/>
-              </a:spcAft>
-              <a:buSzPct val="100000"/>
-              <a:buFont typeface="+mj-lt"/>
-              <a:buAutoNum type="arabicPeriod" startAt="1"/>
-            </a:pPr>
-            <a:r>
-              <a:rPr lang="en-US" sz="4000" dirty="0">
-                <a:solidFill>
-                  <a:srgbClr val="111111"/>
-                </a:solidFill>
-                <a:latin typeface="Times New Roman" pitchFamily="34" charset="0"/>
-                <a:ea typeface="Times New Roman" pitchFamily="34" charset="-122"/>
-                <a:cs typeface="Times New Roman" pitchFamily="34" charset="-120"/>
-              </a:rPr>
-              <a:t>Births minus deaths is natural ______.</a:t>
-            </a:r>
-            <a:endParaRPr lang="en-US" sz="4000" dirty="0"/>
-          </a:p>
-          <a:p>
-            <a:pPr algn="l" marL="342900" indent="-342900">
-              <a:spcAft>
-                <a:spcPts val="800"/>
-              </a:spcAft>
-              <a:buSzPct val="100000"/>
-              <a:buFont typeface="+mj-lt"/>
-              <a:buAutoNum type="arabicPeriod" startAt="1"/>
-            </a:pPr>
-            <a:r>
-              <a:rPr lang="en-US" sz="4000" dirty="0">
-                <a:solidFill>
-                  <a:srgbClr val="111111"/>
-                </a:solidFill>
-                <a:latin typeface="Times New Roman" pitchFamily="34" charset="0"/>
-                <a:ea typeface="Times New Roman" pitchFamily="34" charset="-122"/>
-                <a:cs typeface="Times New Roman" pitchFamily="34" charset="-120"/>
-              </a:rPr>
-              <a:t>Vaccines reduce the ______ rate.</a:t>
+              <a:t>A high birth rate and a falling death rate.</a:t>
             </a:r>
             <a:endParaRPr lang="en-US" sz="4000" dirty="0"/>
           </a:p>
@@ -16293,7 +16723,7 @@
                 <a:ea typeface="Calibri" pitchFamily="34" charset="-122"/>
                 <a:cs typeface="Calibri" pitchFamily="34" charset="-120"/>
               </a:rPr>
-              <a:t>HOMEWORK</a:t>
+              <a:t>FORMATIVE EVALUATION</a:t>
             </a:r>
             <a:endParaRPr lang="en-US" sz="1400" dirty="0"/>
           </a:p>
@@ -16358,7 +16788,7 @@
                 <a:ea typeface="Times New Roman" pitchFamily="34" charset="-122"/>
                 <a:cs typeface="Times New Roman" pitchFamily="34" charset="-120"/>
               </a:rPr>
-              <a:t>Homework</a:t>
+              <a:t>Evaluation 2</a:t>
             </a:r>
             <a:endParaRPr lang="en-US" sz="3600" dirty="0"/>
           </a:p>
@@ -16400,7 +16830,7 @@
                 <a:ea typeface="Times New Roman" pitchFamily="34" charset="-122"/>
                 <a:cs typeface="Times New Roman" pitchFamily="34" charset="-120"/>
               </a:rPr>
-              <a:t>Ask your parents how many brothers and sisters they had and compare with families today.</a:t>
+              <a:t>Give two effects on natural resources.</a:t>
             </a:r>
             <a:endParaRPr lang="en-US" sz="4000" dirty="0"/>
           </a:p>
@@ -16512,7 +16942,7 @@
                 <a:ea typeface="Calibri" pitchFamily="34" charset="-122"/>
                 <a:cs typeface="Calibri" pitchFamily="34" charset="-120"/>
               </a:rPr>
-              <a:t>NEXT LESSON</a:t>
+              <a:t>FORMATIVE EVALUATION</a:t>
             </a:r>
             <a:endParaRPr lang="en-US" sz="1400" dirty="0"/>
           </a:p>
@@ -16577,7 +17007,7 @@
                 <a:ea typeface="Times New Roman" pitchFamily="34" charset="-122"/>
                 <a:cs typeface="Times New Roman" pitchFamily="34" charset="-120"/>
               </a:rPr>
-              <a:t>Next Lesson</a:t>
+              <a:t>Expected Answer</a:t>
             </a:r>
             <a:endParaRPr lang="en-US" sz="3600" dirty="0"/>
           </a:p>
@@ -16601,17 +17031,17 @@
           <a:ln/>
         </p:spPr>
         <p:txBody>
-          <a:bodyPr wrap="square" lIns="0" tIns="0" rIns="0" bIns="0" rtlCol="0" anchor="ctr"/>
-          <a:lstStyle/>
-          <a:p>
-            <a:pPr algn="ctr" indent="0" marL="0">
+          <a:bodyPr wrap="square" lIns="0" tIns="0" rIns="0" bIns="0" rtlCol="0" anchor="t"/>
+          <a:lstStyle/>
+          <a:p>
+            <a:pPr algn="l" indent="0" marL="0">
               <a:spcAft>
                 <a:spcPts val="800"/>
               </a:spcAft>
               <a:buNone/>
             </a:pPr>
             <a:r>
-              <a:rPr lang="en-US" sz="4000" b="1" dirty="0">
+              <a:rPr lang="en-US" sz="4000" dirty="0">
                 <a:solidFill>
                   <a:srgbClr val="111111"/>
                 </a:solidFill>
@@ -16619,27 +17049,7 @@
                 <a:ea typeface="Times New Roman" pitchFamily="34" charset="-122"/>
                 <a:cs typeface="Times New Roman" pitchFamily="34" charset="-120"/>
               </a:rPr>
-              <a:t>Our next lesson will be on:</a:t>
-            </a:r>
-            <a:endParaRPr lang="en-US" sz="4000" dirty="0"/>
-          </a:p>
-          <a:p>
-            <a:pPr algn="ctr" indent="0" marL="0">
-              <a:spcAft>
-                <a:spcPts val="800"/>
-              </a:spcAft>
-              <a:buNone/>
-            </a:pPr>
-            <a:r>
-              <a:rPr lang="en-US" sz="4000" b="1" dirty="0">
-                <a:solidFill>
-                  <a:srgbClr val="990011"/>
-                </a:solidFill>
-                <a:latin typeface="Times New Roman" pitchFamily="34" charset="0"/>
-                <a:ea typeface="Times New Roman" pitchFamily="34" charset="-122"/>
-                <a:cs typeface="Times New Roman" pitchFamily="34" charset="-120"/>
-              </a:rPr>
-              <a:t>Practical Work 1: Calculation of the Demographic Indices of Cameroon</a:t>
+              <a:t>Deforestation and shortage of land.</a:t>
             </a:r>
             <a:endParaRPr lang="en-US" sz="4000" dirty="0"/>
           </a:p>
@@ -16751,6 +17161,1012 @@
                 <a:ea typeface="Calibri" pitchFamily="34" charset="-122"/>
                 <a:cs typeface="Calibri" pitchFamily="34" charset="-120"/>
               </a:rPr>
+              <a:t>REMEDIATION</a:t>
+            </a:r>
+            <a:endParaRPr lang="en-US" sz="1400" dirty="0"/>
+          </a:p>
+        </p:txBody>
+      </p:sp>
+      <p:pic>
+        <p:nvPicPr>
+          <p:cNvPr id="3" name="Image 0" descr="/home/claude/f4/img/minesec_sheet.png">    </p:cNvPr>
+          <p:cNvPicPr>
+            <a:picLocks noChangeAspect="1"/>
+          </p:cNvPicPr>
+          <p:nvPr/>
+        </p:nvPicPr>
+        <p:blipFill>
+          <a:blip r:embed="rId1"/>
+          <a:stretch>
+            <a:fillRect/>
+          </a:stretch>
+        </p:blipFill>
+        <p:spPr>
+          <a:xfrm>
+            <a:off x="0" y="658368"/>
+            <a:ext cx="3840480" cy="5833872"/>
+          </a:xfrm>
+          <a:prstGeom prst="rect">
+            <a:avLst/>
+          </a:prstGeom>
+        </p:spPr>
+      </p:pic>
+      <p:sp>
+        <p:nvSpPr>
+          <p:cNvPr id="4" name="Text 1"/>
+          <p:cNvSpPr/>
+          <p:nvPr/>
+        </p:nvSpPr>
+        <p:spPr>
+          <a:xfrm>
+            <a:off x="4069080" y="1005840"/>
+            <a:ext cx="7802575" cy="731520"/>
+          </a:xfrm>
+          <a:prstGeom prst="rect">
+            <a:avLst/>
+          </a:prstGeom>
+          <a:noFill/>
+          <a:ln/>
+        </p:spPr>
+        <p:txBody>
+          <a:bodyPr wrap="square" lIns="0" tIns="0" rIns="0" bIns="0" rtlCol="0" anchor="ctr">
+            <a:normAutofit/>
+          </a:bodyPr>
+          <a:lstStyle/>
+          <a:p>
+            <a:pPr algn="ctr" indent="0" marL="0">
+              <a:buNone/>
+            </a:pPr>
+            <a:r>
+              <a:rPr lang="en-US" sz="3600" b="1" dirty="0">
+                <a:solidFill>
+                  <a:srgbClr val="990011"/>
+                </a:solidFill>
+                <a:latin typeface="Times New Roman" pitchFamily="34" charset="0"/>
+                <a:ea typeface="Times New Roman" pitchFamily="34" charset="-122"/>
+                <a:cs typeface="Times New Roman" pitchFamily="34" charset="-120"/>
+              </a:rPr>
+              <a:t>Remediation</a:t>
+            </a:r>
+            <a:endParaRPr lang="en-US" sz="3600" dirty="0"/>
+          </a:p>
+        </p:txBody>
+      </p:sp>
+      <p:sp>
+        <p:nvSpPr>
+          <p:cNvPr id="5" name="Text 2"/>
+          <p:cNvSpPr/>
+          <p:nvPr/>
+        </p:nvSpPr>
+        <p:spPr>
+          <a:xfrm>
+            <a:off x="4069080" y="1783080"/>
+            <a:ext cx="7802575" cy="4663440"/>
+          </a:xfrm>
+          <a:prstGeom prst="rect">
+            <a:avLst/>
+          </a:prstGeom>
+          <a:noFill/>
+          <a:ln/>
+        </p:spPr>
+        <p:txBody>
+          <a:bodyPr wrap="square" lIns="0" tIns="0" rIns="0" bIns="0" rtlCol="0" anchor="t"/>
+          <a:lstStyle/>
+          <a:p>
+            <a:pPr algn="l" indent="0" marL="0">
+              <a:spcAft>
+                <a:spcPts val="800"/>
+              </a:spcAft>
+              <a:buNone/>
+            </a:pPr>
+            <a:r>
+              <a:rPr lang="en-US" sz="4000" b="1" dirty="0">
+                <a:solidFill>
+                  <a:srgbClr val="111111"/>
+                </a:solidFill>
+                <a:latin typeface="Times New Roman" pitchFamily="34" charset="0"/>
+                <a:ea typeface="Times New Roman" pitchFamily="34" charset="-122"/>
+                <a:cs typeface="Times New Roman" pitchFamily="34" charset="-120"/>
+              </a:rPr>
+              <a:t>Fill in the blanks:</a:t>
+            </a:r>
+            <a:endParaRPr lang="en-US" sz="4000" dirty="0"/>
+          </a:p>
+          <a:p>
+            <a:pPr algn="l" marL="342900" indent="-342900">
+              <a:spcAft>
+                <a:spcPts val="800"/>
+              </a:spcAft>
+              <a:buSzPct val="100000"/>
+              <a:buFont typeface="+mj-lt"/>
+              <a:buAutoNum type="arabicPeriod" startAt="1"/>
+            </a:pPr>
+            <a:r>
+              <a:rPr lang="en-US" sz="4000" dirty="0">
+                <a:solidFill>
+                  <a:srgbClr val="111111"/>
+                </a:solidFill>
+                <a:latin typeface="Times New Roman" pitchFamily="34" charset="0"/>
+                <a:ea typeface="Times New Roman" pitchFamily="34" charset="-122"/>
+                <a:cs typeface="Times New Roman" pitchFamily="34" charset="-120"/>
+              </a:rPr>
+              <a:t>The world population passed ______ billion in 2022.</a:t>
+            </a:r>
+            <a:endParaRPr lang="en-US" sz="4000" dirty="0"/>
+          </a:p>
+          <a:p>
+            <a:pPr algn="l" marL="342900" indent="-342900">
+              <a:spcAft>
+                <a:spcPts val="800"/>
+              </a:spcAft>
+              <a:buSzPct val="100000"/>
+              <a:buFont typeface="+mj-lt"/>
+              <a:buAutoNum type="arabicPeriod" startAt="1"/>
+            </a:pPr>
+            <a:r>
+              <a:rPr lang="en-US" sz="4000" dirty="0">
+                <a:solidFill>
+                  <a:srgbClr val="111111"/>
+                </a:solidFill>
+                <a:latin typeface="Times New Roman" pitchFamily="34" charset="0"/>
+                <a:ea typeface="Times New Roman" pitchFamily="34" charset="-122"/>
+                <a:cs typeface="Times New Roman" pitchFamily="34" charset="-120"/>
+              </a:rPr>
+              <a:t>Births minus deaths is natural ______.</a:t>
+            </a:r>
+            <a:endParaRPr lang="en-US" sz="4000" dirty="0"/>
+          </a:p>
+          <a:p>
+            <a:pPr algn="l" marL="342900" indent="-342900">
+              <a:spcAft>
+                <a:spcPts val="800"/>
+              </a:spcAft>
+              <a:buSzPct val="100000"/>
+              <a:buFont typeface="+mj-lt"/>
+              <a:buAutoNum type="arabicPeriod" startAt="1"/>
+            </a:pPr>
+            <a:r>
+              <a:rPr lang="en-US" sz="4000" dirty="0">
+                <a:solidFill>
+                  <a:srgbClr val="111111"/>
+                </a:solidFill>
+                <a:latin typeface="Times New Roman" pitchFamily="34" charset="0"/>
+                <a:ea typeface="Times New Roman" pitchFamily="34" charset="-122"/>
+                <a:cs typeface="Times New Roman" pitchFamily="34" charset="-120"/>
+              </a:rPr>
+              <a:t>Vaccines reduce the ______ rate.</a:t>
+            </a:r>
+            <a:endParaRPr lang="en-US" sz="4000" dirty="0"/>
+          </a:p>
+        </p:txBody>
+      </p:sp>
+      <p:sp>
+        <p:nvSpPr>
+          <p:cNvPr id="25" name="Slide Number Placeholder 0"/>
+          <p:cNvSpPr>
+            <a:spLocks noGrp="1"/>
+          </p:cNvSpPr>
+          <p:nvPr>
+            <p:ph type="sldNum" sz="quarter" idx="4294967295"/>
+          </p:nvPr>
+        </p:nvSpPr>
+        <p:spPr>
+          <a:xfrm>
+            <a:off x="27432" y="91440"/>
+            <a:ext cx="585216" cy="475488"/>
+          </a:xfrm>
+          <a:prstGeom prst="rect">
+            <a:avLst/>
+          </a:prstGeom>
+          <a:extLst>
+            <a:ext uri="{C572A759-6A51-4108-AA02-DFA0A04FC94B}">
+              <ma14:wrappingTextBoxFlag xmlns:ma14="http://schemas.microsoft.com/office/mac/drawingml/2011/main" val="0"/>
+            </a:ext>
+          </a:extLst>
+        </p:spPr>
+        <p:txBody>
+          <a:bodyPr/>
+          <a:lstStyle>
+            <a:lvl1pPr>
+              <a:defRPr sz="2000">
+                <a:solidFill>
+                  <a:srgbClr val="FFFFFF"/>
+                </a:solidFill>
+                <a:latin typeface="Calibri"/>
+                <a:ea typeface="Calibri"/>
+                <a:cs typeface="Calibri"/>
+              </a:defRPr>
+            </a:lvl1pPr>
+          </a:lstStyle>
+          <a:p>
+            <a:pPr algn="ctr"/>
+            <a:fld id="{F7021451-1387-4CA6-816F-3879F97B5CBC}" type="slidenum">
+              <a:rPr b="1" lang="en-US"/>
+              <a:t>47</a:t>
+            </a:fld>
+            <a:endParaRPr lang="en-US"/>
+          </a:p>
+        </p:txBody>
+      </p:sp>
+    </p:spTree>
+  </p:cSld>
+  <p:clrMapOvr>
+    <a:masterClrMapping/>
+  </p:clrMapOvr>
+</p:sld>
+</file>
+
+<file path=ppt/slides/slide48.xml><?xml version="1.0" encoding="utf-8"?>
+<p:sld xmlns:a="http://schemas.openxmlformats.org/drawingml/2006/main" xmlns:r="http://schemas.openxmlformats.org/officeDocument/2006/relationships" xmlns:p="http://schemas.openxmlformats.org/presentationml/2006/main">
+  <p:cSld name="Slide 48">
+    <p:spTree>
+      <p:nvGrpSpPr>
+        <p:cNvPr id="1" name=""/>
+        <p:cNvGrpSpPr/>
+        <p:nvPr/>
+      </p:nvGrpSpPr>
+      <p:grpSpPr>
+        <a:xfrm>
+          <a:off x="0" y="0"/>
+          <a:ext cx="0" cy="0"/>
+          <a:chOff x="0" y="0"/>
+          <a:chExt cx="0" cy="0"/>
+        </a:xfrm>
+      </p:grpSpPr>
+      <p:sp>
+        <p:nvSpPr>
+          <p:cNvPr id="2" name="Text 0"/>
+          <p:cNvSpPr/>
+          <p:nvPr/>
+        </p:nvSpPr>
+        <p:spPr>
+          <a:xfrm>
+            <a:off x="457200" y="713232"/>
+            <a:ext cx="11368735" cy="274320"/>
+          </a:xfrm>
+          <a:prstGeom prst="rect">
+            <a:avLst/>
+          </a:prstGeom>
+          <a:noFill/>
+          <a:ln/>
+        </p:spPr>
+        <p:txBody>
+          <a:bodyPr wrap="square" lIns="0" tIns="0" rIns="0" bIns="0" rtlCol="0" anchor="ctr"/>
+          <a:lstStyle/>
+          <a:p>
+            <a:pPr algn="r" indent="0" marL="0">
+              <a:buNone/>
+            </a:pPr>
+            <a:r>
+              <a:rPr lang="en-US" sz="1400" b="1" dirty="0">
+                <a:solidFill>
+                  <a:srgbClr val="1C3F6E"/>
+                </a:solidFill>
+                <a:latin typeface="Calibri" pitchFamily="34" charset="0"/>
+                <a:ea typeface="Calibri" pitchFamily="34" charset="-122"/>
+                <a:cs typeface="Calibri" pitchFamily="34" charset="-120"/>
+              </a:rPr>
+              <a:t>HOMEWORK</a:t>
+            </a:r>
+            <a:endParaRPr lang="en-US" sz="1400" dirty="0"/>
+          </a:p>
+        </p:txBody>
+      </p:sp>
+      <p:pic>
+        <p:nvPicPr>
+          <p:cNvPr id="3" name="Image 0" descr="/home/claude/f4/img/minesec_sheet.png">    </p:cNvPr>
+          <p:cNvPicPr>
+            <a:picLocks noChangeAspect="1"/>
+          </p:cNvPicPr>
+          <p:nvPr/>
+        </p:nvPicPr>
+        <p:blipFill>
+          <a:blip r:embed="rId1"/>
+          <a:stretch>
+            <a:fillRect/>
+          </a:stretch>
+        </p:blipFill>
+        <p:spPr>
+          <a:xfrm>
+            <a:off x="0" y="658368"/>
+            <a:ext cx="5120640" cy="5833872"/>
+          </a:xfrm>
+          <a:prstGeom prst="rect">
+            <a:avLst/>
+          </a:prstGeom>
+        </p:spPr>
+      </p:pic>
+      <p:sp>
+        <p:nvSpPr>
+          <p:cNvPr id="4" name="Text 1"/>
+          <p:cNvSpPr/>
+          <p:nvPr/>
+        </p:nvSpPr>
+        <p:spPr>
+          <a:xfrm>
+            <a:off x="5349240" y="1005840"/>
+            <a:ext cx="6522415" cy="731520"/>
+          </a:xfrm>
+          <a:prstGeom prst="rect">
+            <a:avLst/>
+          </a:prstGeom>
+          <a:noFill/>
+          <a:ln/>
+        </p:spPr>
+        <p:txBody>
+          <a:bodyPr wrap="square" lIns="0" tIns="0" rIns="0" bIns="0" rtlCol="0" anchor="ctr">
+            <a:normAutofit/>
+          </a:bodyPr>
+          <a:lstStyle/>
+          <a:p>
+            <a:pPr algn="ctr" indent="0" marL="0">
+              <a:buNone/>
+            </a:pPr>
+            <a:r>
+              <a:rPr lang="en-US" sz="3600" b="1" dirty="0">
+                <a:solidFill>
+                  <a:srgbClr val="990011"/>
+                </a:solidFill>
+                <a:latin typeface="Times New Roman" pitchFamily="34" charset="0"/>
+                <a:ea typeface="Times New Roman" pitchFamily="34" charset="-122"/>
+                <a:cs typeface="Times New Roman" pitchFamily="34" charset="-120"/>
+              </a:rPr>
+              <a:t>Homework</a:t>
+            </a:r>
+            <a:endParaRPr lang="en-US" sz="3600" dirty="0"/>
+          </a:p>
+        </p:txBody>
+      </p:sp>
+      <p:sp>
+        <p:nvSpPr>
+          <p:cNvPr id="5" name="Text 2"/>
+          <p:cNvSpPr/>
+          <p:nvPr/>
+        </p:nvSpPr>
+        <p:spPr>
+          <a:xfrm>
+            <a:off x="5349240" y="1783080"/>
+            <a:ext cx="6522415" cy="4663440"/>
+          </a:xfrm>
+          <a:prstGeom prst="rect">
+            <a:avLst/>
+          </a:prstGeom>
+          <a:noFill/>
+          <a:ln/>
+        </p:spPr>
+        <p:txBody>
+          <a:bodyPr wrap="square" lIns="0" tIns="0" rIns="0" bIns="0" rtlCol="0" anchor="t"/>
+          <a:lstStyle/>
+          <a:p>
+            <a:pPr algn="l" indent="0" marL="0">
+              <a:spcAft>
+                <a:spcPts val="800"/>
+              </a:spcAft>
+              <a:buNone/>
+            </a:pPr>
+            <a:r>
+              <a:rPr lang="en-US" sz="4000" dirty="0">
+                <a:solidFill>
+                  <a:srgbClr val="111111"/>
+                </a:solidFill>
+                <a:latin typeface="Times New Roman" pitchFamily="34" charset="0"/>
+                <a:ea typeface="Times New Roman" pitchFamily="34" charset="-122"/>
+                <a:cs typeface="Times New Roman" pitchFamily="34" charset="-120"/>
+              </a:rPr>
+              <a:t>Ask your parents how many brothers and sisters they had and compare with families today.</a:t>
+            </a:r>
+            <a:endParaRPr lang="en-US" sz="4000" dirty="0"/>
+          </a:p>
+        </p:txBody>
+      </p:sp>
+      <p:sp>
+        <p:nvSpPr>
+          <p:cNvPr id="25" name="Slide Number Placeholder 0"/>
+          <p:cNvSpPr>
+            <a:spLocks noGrp="1"/>
+          </p:cNvSpPr>
+          <p:nvPr>
+            <p:ph type="sldNum" sz="quarter" idx="4294967295"/>
+          </p:nvPr>
+        </p:nvSpPr>
+        <p:spPr>
+          <a:xfrm>
+            <a:off x="27432" y="91440"/>
+            <a:ext cx="585216" cy="475488"/>
+          </a:xfrm>
+          <a:prstGeom prst="rect">
+            <a:avLst/>
+          </a:prstGeom>
+          <a:extLst>
+            <a:ext uri="{C572A759-6A51-4108-AA02-DFA0A04FC94B}">
+              <ma14:wrappingTextBoxFlag xmlns:ma14="http://schemas.microsoft.com/office/mac/drawingml/2011/main" val="0"/>
+            </a:ext>
+          </a:extLst>
+        </p:spPr>
+        <p:txBody>
+          <a:bodyPr/>
+          <a:lstStyle>
+            <a:lvl1pPr>
+              <a:defRPr sz="2000">
+                <a:solidFill>
+                  <a:srgbClr val="FFFFFF"/>
+                </a:solidFill>
+                <a:latin typeface="Calibri"/>
+                <a:ea typeface="Calibri"/>
+                <a:cs typeface="Calibri"/>
+              </a:defRPr>
+            </a:lvl1pPr>
+          </a:lstStyle>
+          <a:p>
+            <a:pPr algn="ctr"/>
+            <a:fld id="{F7021451-1387-4CA6-816F-3879F97B5CBC}" type="slidenum">
+              <a:rPr b="1" lang="en-US"/>
+              <a:t>48</a:t>
+            </a:fld>
+            <a:endParaRPr lang="en-US"/>
+          </a:p>
+        </p:txBody>
+      </p:sp>
+    </p:spTree>
+  </p:cSld>
+  <p:clrMapOvr>
+    <a:masterClrMapping/>
+  </p:clrMapOvr>
+</p:sld>
+</file>
+
+<file path=ppt/slides/slide49.xml><?xml version="1.0" encoding="utf-8"?>
+<p:sld xmlns:a="http://schemas.openxmlformats.org/drawingml/2006/main" xmlns:r="http://schemas.openxmlformats.org/officeDocument/2006/relationships" xmlns:p="http://schemas.openxmlformats.org/presentationml/2006/main">
+  <p:cSld name="Slide 49">
+    <p:spTree>
+      <p:nvGrpSpPr>
+        <p:cNvPr id="1" name=""/>
+        <p:cNvGrpSpPr/>
+        <p:nvPr/>
+      </p:nvGrpSpPr>
+      <p:grpSpPr>
+        <a:xfrm>
+          <a:off x="0" y="0"/>
+          <a:ext cx="0" cy="0"/>
+          <a:chOff x="0" y="0"/>
+          <a:chExt cx="0" cy="0"/>
+        </a:xfrm>
+      </p:grpSpPr>
+      <p:sp>
+        <p:nvSpPr>
+          <p:cNvPr id="2" name="Text 0"/>
+          <p:cNvSpPr/>
+          <p:nvPr/>
+        </p:nvSpPr>
+        <p:spPr>
+          <a:xfrm>
+            <a:off x="457200" y="713232"/>
+            <a:ext cx="11368735" cy="274320"/>
+          </a:xfrm>
+          <a:prstGeom prst="rect">
+            <a:avLst/>
+          </a:prstGeom>
+          <a:noFill/>
+          <a:ln/>
+        </p:spPr>
+        <p:txBody>
+          <a:bodyPr wrap="square" lIns="0" tIns="0" rIns="0" bIns="0" rtlCol="0" anchor="ctr"/>
+          <a:lstStyle/>
+          <a:p>
+            <a:pPr algn="r" indent="0" marL="0">
+              <a:buNone/>
+            </a:pPr>
+            <a:r>
+              <a:rPr lang="en-US" sz="1400" b="1" dirty="0">
+                <a:solidFill>
+                  <a:srgbClr val="1C3F6E"/>
+                </a:solidFill>
+                <a:latin typeface="Calibri" pitchFamily="34" charset="0"/>
+                <a:ea typeface="Calibri" pitchFamily="34" charset="-122"/>
+                <a:cs typeface="Calibri" pitchFamily="34" charset="-120"/>
+              </a:rPr>
+              <a:t>NEXT LESSON</a:t>
+            </a:r>
+            <a:endParaRPr lang="en-US" sz="1400" dirty="0"/>
+          </a:p>
+        </p:txBody>
+      </p:sp>
+      <p:pic>
+        <p:nvPicPr>
+          <p:cNvPr id="3" name="Image 0" descr="/home/claude/f4/img/minesec_sheet.png">    </p:cNvPr>
+          <p:cNvPicPr>
+            <a:picLocks noChangeAspect="1"/>
+          </p:cNvPicPr>
+          <p:nvPr/>
+        </p:nvPicPr>
+        <p:blipFill>
+          <a:blip r:embed="rId1"/>
+          <a:stretch>
+            <a:fillRect/>
+          </a:stretch>
+        </p:blipFill>
+        <p:spPr>
+          <a:xfrm>
+            <a:off x="0" y="658368"/>
+            <a:ext cx="5120640" cy="5833872"/>
+          </a:xfrm>
+          <a:prstGeom prst="rect">
+            <a:avLst/>
+          </a:prstGeom>
+        </p:spPr>
+      </p:pic>
+      <p:sp>
+        <p:nvSpPr>
+          <p:cNvPr id="4" name="Text 1"/>
+          <p:cNvSpPr/>
+          <p:nvPr/>
+        </p:nvSpPr>
+        <p:spPr>
+          <a:xfrm>
+            <a:off x="5349240" y="1005840"/>
+            <a:ext cx="6522415" cy="731520"/>
+          </a:xfrm>
+          <a:prstGeom prst="rect">
+            <a:avLst/>
+          </a:prstGeom>
+          <a:noFill/>
+          <a:ln/>
+        </p:spPr>
+        <p:txBody>
+          <a:bodyPr wrap="square" lIns="0" tIns="0" rIns="0" bIns="0" rtlCol="0" anchor="ctr">
+            <a:normAutofit/>
+          </a:bodyPr>
+          <a:lstStyle/>
+          <a:p>
+            <a:pPr algn="ctr" indent="0" marL="0">
+              <a:buNone/>
+            </a:pPr>
+            <a:r>
+              <a:rPr lang="en-US" sz="3600" b="1" dirty="0">
+                <a:solidFill>
+                  <a:srgbClr val="990011"/>
+                </a:solidFill>
+                <a:latin typeface="Times New Roman" pitchFamily="34" charset="0"/>
+                <a:ea typeface="Times New Roman" pitchFamily="34" charset="-122"/>
+                <a:cs typeface="Times New Roman" pitchFamily="34" charset="-120"/>
+              </a:rPr>
+              <a:t>Next Lesson</a:t>
+            </a:r>
+            <a:endParaRPr lang="en-US" sz="3600" dirty="0"/>
+          </a:p>
+        </p:txBody>
+      </p:sp>
+      <p:sp>
+        <p:nvSpPr>
+          <p:cNvPr id="5" name="Text 2"/>
+          <p:cNvSpPr/>
+          <p:nvPr/>
+        </p:nvSpPr>
+        <p:spPr>
+          <a:xfrm>
+            <a:off x="5349240" y="1783080"/>
+            <a:ext cx="6522415" cy="4663440"/>
+          </a:xfrm>
+          <a:prstGeom prst="rect">
+            <a:avLst/>
+          </a:prstGeom>
+          <a:noFill/>
+          <a:ln/>
+        </p:spPr>
+        <p:txBody>
+          <a:bodyPr wrap="square" lIns="0" tIns="0" rIns="0" bIns="0" rtlCol="0" anchor="ctr"/>
+          <a:lstStyle/>
+          <a:p>
+            <a:pPr algn="ctr" indent="0" marL="0">
+              <a:spcAft>
+                <a:spcPts val="800"/>
+              </a:spcAft>
+              <a:buNone/>
+            </a:pPr>
+            <a:r>
+              <a:rPr lang="en-US" sz="4000" b="1" dirty="0">
+                <a:solidFill>
+                  <a:srgbClr val="111111"/>
+                </a:solidFill>
+                <a:latin typeface="Times New Roman" pitchFamily="34" charset="0"/>
+                <a:ea typeface="Times New Roman" pitchFamily="34" charset="-122"/>
+                <a:cs typeface="Times New Roman" pitchFamily="34" charset="-120"/>
+              </a:rPr>
+              <a:t>Our next lesson will be on:</a:t>
+            </a:r>
+            <a:endParaRPr lang="en-US" sz="4000" dirty="0"/>
+          </a:p>
+          <a:p>
+            <a:pPr algn="ctr" indent="0" marL="0">
+              <a:spcAft>
+                <a:spcPts val="800"/>
+              </a:spcAft>
+              <a:buNone/>
+            </a:pPr>
+            <a:r>
+              <a:rPr lang="en-US" sz="4000" b="1" dirty="0">
+                <a:solidFill>
+                  <a:srgbClr val="990011"/>
+                </a:solidFill>
+                <a:latin typeface="Times New Roman" pitchFamily="34" charset="0"/>
+                <a:ea typeface="Times New Roman" pitchFamily="34" charset="-122"/>
+                <a:cs typeface="Times New Roman" pitchFamily="34" charset="-120"/>
+              </a:rPr>
+              <a:t>Practical Work 1: Calculation of the Demographic Indices of Cameroon</a:t>
+            </a:r>
+            <a:endParaRPr lang="en-US" sz="4000" dirty="0"/>
+          </a:p>
+        </p:txBody>
+      </p:sp>
+      <p:sp>
+        <p:nvSpPr>
+          <p:cNvPr id="25" name="Slide Number Placeholder 0"/>
+          <p:cNvSpPr>
+            <a:spLocks noGrp="1"/>
+          </p:cNvSpPr>
+          <p:nvPr>
+            <p:ph type="sldNum" sz="quarter" idx="4294967295"/>
+          </p:nvPr>
+        </p:nvSpPr>
+        <p:spPr>
+          <a:xfrm>
+            <a:off x="27432" y="91440"/>
+            <a:ext cx="585216" cy="475488"/>
+          </a:xfrm>
+          <a:prstGeom prst="rect">
+            <a:avLst/>
+          </a:prstGeom>
+          <a:extLst>
+            <a:ext uri="{C572A759-6A51-4108-AA02-DFA0A04FC94B}">
+              <ma14:wrappingTextBoxFlag xmlns:ma14="http://schemas.microsoft.com/office/mac/drawingml/2011/main" val="0"/>
+            </a:ext>
+          </a:extLst>
+        </p:spPr>
+        <p:txBody>
+          <a:bodyPr/>
+          <a:lstStyle>
+            <a:lvl1pPr>
+              <a:defRPr sz="2000">
+                <a:solidFill>
+                  <a:srgbClr val="FFFFFF"/>
+                </a:solidFill>
+                <a:latin typeface="Calibri"/>
+                <a:ea typeface="Calibri"/>
+                <a:cs typeface="Calibri"/>
+              </a:defRPr>
+            </a:lvl1pPr>
+          </a:lstStyle>
+          <a:p>
+            <a:pPr algn="ctr"/>
+            <a:fld id="{F7021451-1387-4CA6-816F-3879F97B5CBC}" type="slidenum">
+              <a:rPr b="1" lang="en-US"/>
+              <a:t>49</a:t>
+            </a:fld>
+            <a:endParaRPr lang="en-US"/>
+          </a:p>
+        </p:txBody>
+      </p:sp>
+    </p:spTree>
+  </p:cSld>
+  <p:clrMapOvr>
+    <a:masterClrMapping/>
+  </p:clrMapOvr>
+</p:sld>
+</file>
+
+<file path=ppt/slides/slide5.xml><?xml version="1.0" encoding="utf-8"?>
+<p:sld xmlns:a="http://schemas.openxmlformats.org/drawingml/2006/main" xmlns:r="http://schemas.openxmlformats.org/officeDocument/2006/relationships" xmlns:p="http://schemas.openxmlformats.org/presentationml/2006/main">
+  <p:cSld name="Slide 5">
+    <p:spTree>
+      <p:nvGrpSpPr>
+        <p:cNvPr id="1" name=""/>
+        <p:cNvGrpSpPr/>
+        <p:nvPr/>
+      </p:nvGrpSpPr>
+      <p:grpSpPr>
+        <a:xfrm>
+          <a:off x="0" y="0"/>
+          <a:ext cx="0" cy="0"/>
+          <a:chOff x="0" y="0"/>
+          <a:chExt cx="0" cy="0"/>
+        </a:xfrm>
+      </p:grpSpPr>
+      <p:sp>
+        <p:nvSpPr>
+          <p:cNvPr id="2" name="Text 0"/>
+          <p:cNvSpPr/>
+          <p:nvPr/>
+        </p:nvSpPr>
+        <p:spPr>
+          <a:xfrm>
+            <a:off x="457200" y="713232"/>
+            <a:ext cx="11368735" cy="274320"/>
+          </a:xfrm>
+          <a:prstGeom prst="rect">
+            <a:avLst/>
+          </a:prstGeom>
+          <a:noFill/>
+          <a:ln/>
+        </p:spPr>
+        <p:txBody>
+          <a:bodyPr wrap="square" lIns="0" tIns="0" rIns="0" bIns="0" rtlCol="0" anchor="ctr"/>
+          <a:lstStyle/>
+          <a:p>
+            <a:pPr algn="r" indent="0" marL="0">
+              <a:buNone/>
+            </a:pPr>
+            <a:r>
+              <a:rPr lang="en-US" sz="1400" b="1" dirty="0">
+                <a:solidFill>
+                  <a:srgbClr val="1C3F6E"/>
+                </a:solidFill>
+                <a:latin typeface="Calibri" pitchFamily="34" charset="0"/>
+                <a:ea typeface="Calibri" pitchFamily="34" charset="-122"/>
+                <a:cs typeface="Calibri" pitchFamily="34" charset="-120"/>
+              </a:rPr>
+              <a:t>OBJECTIVES</a:t>
+            </a:r>
+            <a:endParaRPr lang="en-US" sz="1400" dirty="0"/>
+          </a:p>
+        </p:txBody>
+      </p:sp>
+      <p:pic>
+        <p:nvPicPr>
+          <p:cNvPr id="3" name="Image 0" descr="/home/claude/f4/img/minesec_sheet.png">    </p:cNvPr>
+          <p:cNvPicPr>
+            <a:picLocks noChangeAspect="1"/>
+          </p:cNvPicPr>
+          <p:nvPr/>
+        </p:nvPicPr>
+        <p:blipFill>
+          <a:blip r:embed="rId1"/>
+          <a:stretch>
+            <a:fillRect/>
+          </a:stretch>
+        </p:blipFill>
+        <p:spPr>
+          <a:xfrm>
+            <a:off x="0" y="658368"/>
+            <a:ext cx="5120640" cy="5833872"/>
+          </a:xfrm>
+          <a:prstGeom prst="rect">
+            <a:avLst/>
+          </a:prstGeom>
+        </p:spPr>
+      </p:pic>
+      <p:sp>
+        <p:nvSpPr>
+          <p:cNvPr id="4" name="Text 1"/>
+          <p:cNvSpPr/>
+          <p:nvPr/>
+        </p:nvSpPr>
+        <p:spPr>
+          <a:xfrm>
+            <a:off x="5349240" y="1005840"/>
+            <a:ext cx="6522415" cy="731520"/>
+          </a:xfrm>
+          <a:prstGeom prst="rect">
+            <a:avLst/>
+          </a:prstGeom>
+          <a:noFill/>
+          <a:ln/>
+        </p:spPr>
+        <p:txBody>
+          <a:bodyPr wrap="square" lIns="0" tIns="0" rIns="0" bIns="0" rtlCol="0" anchor="ctr">
+            <a:normAutofit/>
+          </a:bodyPr>
+          <a:lstStyle/>
+          <a:p>
+            <a:pPr algn="ctr" indent="0" marL="0">
+              <a:buNone/>
+            </a:pPr>
+            <a:r>
+              <a:rPr lang="en-US" sz="3600" b="1" dirty="0">
+                <a:solidFill>
+                  <a:srgbClr val="990011"/>
+                </a:solidFill>
+                <a:latin typeface="Times New Roman" pitchFamily="34" charset="0"/>
+                <a:ea typeface="Times New Roman" pitchFamily="34" charset="-122"/>
+                <a:cs typeface="Times New Roman" pitchFamily="34" charset="-120"/>
+              </a:rPr>
+              <a:t>Objectives</a:t>
+            </a:r>
+            <a:endParaRPr lang="en-US" sz="3600" dirty="0"/>
+          </a:p>
+        </p:txBody>
+      </p:sp>
+      <p:sp>
+        <p:nvSpPr>
+          <p:cNvPr id="5" name="Text 2"/>
+          <p:cNvSpPr/>
+          <p:nvPr/>
+        </p:nvSpPr>
+        <p:spPr>
+          <a:xfrm>
+            <a:off x="5349240" y="1783080"/>
+            <a:ext cx="6522415" cy="4663440"/>
+          </a:xfrm>
+          <a:prstGeom prst="rect">
+            <a:avLst/>
+          </a:prstGeom>
+          <a:noFill/>
+          <a:ln/>
+        </p:spPr>
+        <p:txBody>
+          <a:bodyPr wrap="square" lIns="0" tIns="0" rIns="0" bIns="0" rtlCol="0" anchor="t"/>
+          <a:lstStyle/>
+          <a:p>
+            <a:pPr algn="l" indent="0" marL="0">
+              <a:spcAft>
+                <a:spcPts val="800"/>
+              </a:spcAft>
+              <a:buNone/>
+            </a:pPr>
+            <a:r>
+              <a:rPr lang="en-US" sz="4000" b="1" dirty="0">
+                <a:solidFill>
+                  <a:srgbClr val="111111"/>
+                </a:solidFill>
+                <a:latin typeface="Times New Roman" pitchFamily="34" charset="0"/>
+                <a:ea typeface="Times New Roman" pitchFamily="34" charset="-122"/>
+                <a:cs typeface="Times New Roman" pitchFamily="34" charset="-120"/>
+              </a:rPr>
+              <a:t>By the end of this lesson, you should be able to:</a:t>
+            </a:r>
+            <a:endParaRPr lang="en-US" sz="4000" dirty="0"/>
+          </a:p>
+          <a:p>
+            <a:pPr algn="l" marL="342900" indent="-342900">
+              <a:spcAft>
+                <a:spcPts val="800"/>
+              </a:spcAft>
+              <a:buSzPct val="100000"/>
+              <a:buFont typeface="+mj-lt"/>
+              <a:buAutoNum type="arabicPeriod" startAt="1"/>
+            </a:pPr>
+            <a:r>
+              <a:rPr lang="en-US" sz="4000" dirty="0">
+                <a:solidFill>
+                  <a:srgbClr val="111111"/>
+                </a:solidFill>
+                <a:latin typeface="Times New Roman" pitchFamily="34" charset="0"/>
+                <a:ea typeface="Times New Roman" pitchFamily="34" charset="-122"/>
+                <a:cs typeface="Times New Roman" pitchFamily="34" charset="-120"/>
+              </a:rPr>
+              <a:t>Describe the evolution of the world's population.</a:t>
+            </a:r>
+            <a:endParaRPr lang="en-US" sz="4000" dirty="0"/>
+          </a:p>
+          <a:p>
+            <a:pPr algn="l" marL="342900" indent="-342900">
+              <a:spcAft>
+                <a:spcPts val="800"/>
+              </a:spcAft>
+              <a:buSzPct val="100000"/>
+              <a:buFont typeface="+mj-lt"/>
+              <a:buAutoNum type="arabicPeriod" startAt="1"/>
+            </a:pPr>
+            <a:r>
+              <a:rPr lang="en-US" sz="4000" dirty="0">
+                <a:solidFill>
+                  <a:srgbClr val="111111"/>
+                </a:solidFill>
+                <a:latin typeface="Times New Roman" pitchFamily="34" charset="0"/>
+                <a:ea typeface="Times New Roman" pitchFamily="34" charset="-122"/>
+                <a:cs typeface="Times New Roman" pitchFamily="34" charset="-120"/>
+              </a:rPr>
+              <a:t>Explain the factors of population growth.</a:t>
+            </a:r>
+            <a:endParaRPr lang="en-US" sz="4000" dirty="0"/>
+          </a:p>
+        </p:txBody>
+      </p:sp>
+      <p:sp>
+        <p:nvSpPr>
+          <p:cNvPr id="25" name="Slide Number Placeholder 0"/>
+          <p:cNvSpPr>
+            <a:spLocks noGrp="1"/>
+          </p:cNvSpPr>
+          <p:nvPr>
+            <p:ph type="sldNum" sz="quarter" idx="4294967295"/>
+          </p:nvPr>
+        </p:nvSpPr>
+        <p:spPr>
+          <a:xfrm>
+            <a:off x="27432" y="91440"/>
+            <a:ext cx="585216" cy="475488"/>
+          </a:xfrm>
+          <a:prstGeom prst="rect">
+            <a:avLst/>
+          </a:prstGeom>
+          <a:extLst>
+            <a:ext uri="{C572A759-6A51-4108-AA02-DFA0A04FC94B}">
+              <ma14:wrappingTextBoxFlag xmlns:ma14="http://schemas.microsoft.com/office/mac/drawingml/2011/main" val="0"/>
+            </a:ext>
+          </a:extLst>
+        </p:spPr>
+        <p:txBody>
+          <a:bodyPr/>
+          <a:lstStyle>
+            <a:lvl1pPr>
+              <a:defRPr sz="2000">
+                <a:solidFill>
+                  <a:srgbClr val="FFFFFF"/>
+                </a:solidFill>
+                <a:latin typeface="Calibri"/>
+                <a:ea typeface="Calibri"/>
+                <a:cs typeface="Calibri"/>
+              </a:defRPr>
+            </a:lvl1pPr>
+          </a:lstStyle>
+          <a:p>
+            <a:pPr algn="ctr"/>
+            <a:fld id="{F7021451-1387-4CA6-816F-3879F97B5CBC}" type="slidenum">
+              <a:rPr b="1" lang="en-US"/>
+              <a:t>5</a:t>
+            </a:fld>
+            <a:endParaRPr lang="en-US"/>
+          </a:p>
+        </p:txBody>
+      </p:sp>
+    </p:spTree>
+  </p:cSld>
+  <p:clrMapOvr>
+    <a:masterClrMapping/>
+  </p:clrMapOvr>
+</p:sld>
+</file>
+
+<file path=ppt/slides/slide50.xml><?xml version="1.0" encoding="utf-8"?>
+<p:sld xmlns:a="http://schemas.openxmlformats.org/drawingml/2006/main" xmlns:r="http://schemas.openxmlformats.org/officeDocument/2006/relationships" xmlns:p="http://schemas.openxmlformats.org/presentationml/2006/main">
+  <p:cSld name="Slide 50">
+    <p:spTree>
+      <p:nvGrpSpPr>
+        <p:cNvPr id="1" name=""/>
+        <p:cNvGrpSpPr/>
+        <p:nvPr/>
+      </p:nvGrpSpPr>
+      <p:grpSpPr>
+        <a:xfrm>
+          <a:off x="0" y="0"/>
+          <a:ext cx="0" cy="0"/>
+          <a:chOff x="0" y="0"/>
+          <a:chExt cx="0" cy="0"/>
+        </a:xfrm>
+      </p:grpSpPr>
+      <p:sp>
+        <p:nvSpPr>
+          <p:cNvPr id="2" name="Text 0"/>
+          <p:cNvSpPr/>
+          <p:nvPr/>
+        </p:nvSpPr>
+        <p:spPr>
+          <a:xfrm>
+            <a:off x="457200" y="713232"/>
+            <a:ext cx="11368735" cy="274320"/>
+          </a:xfrm>
+          <a:prstGeom prst="rect">
+            <a:avLst/>
+          </a:prstGeom>
+          <a:noFill/>
+          <a:ln/>
+        </p:spPr>
+        <p:txBody>
+          <a:bodyPr wrap="square" lIns="0" tIns="0" rIns="0" bIns="0" rtlCol="0" anchor="ctr"/>
+          <a:lstStyle/>
+          <a:p>
+            <a:pPr algn="r" indent="0" marL="0">
+              <a:buNone/>
+            </a:pPr>
+            <a:r>
+              <a:rPr lang="en-US" sz="1400" b="1" dirty="0">
+                <a:solidFill>
+                  <a:srgbClr val="1C3F6E"/>
+                </a:solidFill>
+                <a:latin typeface="Calibri" pitchFamily="34" charset="0"/>
+                <a:ea typeface="Calibri" pitchFamily="34" charset="-122"/>
+                <a:cs typeface="Calibri" pitchFamily="34" charset="-120"/>
+              </a:rPr>
               <a:t>BILINGUAL GAME</a:t>
             </a:r>
             <a:endParaRPr lang="en-US" sz="1400" dirty="0"/>
@@ -16798,7 +18214,7 @@
       </p:sp>
       <p:graphicFrame>
         <p:nvGraphicFramePr>
-          <p:cNvPr id="48" name="Table 0"/>
+          <p:cNvPr id="51" name="Table 0"/>
           <p:cNvGraphicFramePr>
             <a:graphicFrameLocks noGrp="1"/>
           </p:cNvGraphicFramePr>
@@ -17834,7 +19250,7 @@
             <a:pPr algn="ctr"/>
             <a:fld id="{F7021451-1387-4CA6-816F-3879F97B5CBC}" type="slidenum">
               <a:rPr b="1" lang="en-US"/>
-              <a:t>47</a:t>
+              <a:t>50</a:t>
             </a:fld>
             <a:endParaRPr lang="en-US"/>
           </a:p>
@@ -17848,9 +19264,9 @@
 </p:sld>
 </file>
 
-<file path=ppt/slides/slide48.xml><?xml version="1.0" encoding="utf-8"?>
+<file path=ppt/slides/slide51.xml><?xml version="1.0" encoding="utf-8"?>
 <p:sld xmlns:a="http://schemas.openxmlformats.org/drawingml/2006/main" xmlns:r="http://schemas.openxmlformats.org/officeDocument/2006/relationships" xmlns:p="http://schemas.openxmlformats.org/presentationml/2006/main">
-  <p:cSld name="Slide 48">
+  <p:cSld name="Slide 51">
     <p:spTree>
       <p:nvGrpSpPr>
         <p:cNvPr id="1" name=""/>
@@ -17945,7 +19361,7 @@
       </p:sp>
       <p:graphicFrame>
         <p:nvGraphicFramePr>
-          <p:cNvPr id="49" name="Table 0"/>
+          <p:cNvPr id="52" name="Table 0"/>
           <p:cNvGraphicFramePr>
             <a:graphicFrameLocks noGrp="1"/>
           </p:cNvGraphicFramePr>
@@ -18567,7 +19983,7 @@
             <a:pPr algn="ctr"/>
             <a:fld id="{F7021451-1387-4CA6-816F-3879F97B5CBC}" type="slidenum">
               <a:rPr b="1" lang="en-US"/>
-              <a:t>48</a:t>
+              <a:t>51</a:t>
             </a:fld>
             <a:endParaRPr lang="en-US"/>
           </a:p>
@@ -18581,9 +19997,9 @@
 </p:sld>
 </file>
 
-<file path=ppt/slides/slide49.xml><?xml version="1.0" encoding="utf-8"?>
+<file path=ppt/slides/slide52.xml><?xml version="1.0" encoding="utf-8"?>
 <p:sld xmlns:a="http://schemas.openxmlformats.org/drawingml/2006/main" xmlns:r="http://schemas.openxmlformats.org/officeDocument/2006/relationships" xmlns:p="http://schemas.openxmlformats.org/presentationml/2006/main">
-  <p:cSld name="Slide 49">
+  <p:cSld name="Slide 52">
     <p:spTree>
       <p:nvGrpSpPr>
         <p:cNvPr id="1" name=""/>
@@ -18678,7 +20094,7 @@
       </p:sp>
       <p:graphicFrame>
         <p:nvGraphicFramePr>
-          <p:cNvPr id="50" name="Table 0"/>
+          <p:cNvPr id="53" name="Table 0"/>
           <p:cNvGraphicFramePr>
             <a:graphicFrameLocks noGrp="1"/>
           </p:cNvGraphicFramePr>
@@ -18788,7 +20204,7 @@
                           <a:ea typeface="Calibri" pitchFamily="34" charset="-122"/>
                           <a:cs typeface="Calibri" pitchFamily="34" charset="-120"/>
                         </a:rPr>
-                        <a:t>DEFINITIONS; Evolution of the World's Population; Factors of Population Growth; Implications on Natural Resources.</a:t>
+                        <a:t>DEFINITIONS; Evolution of the World's Population; Factors of the Population Growth; Implications on Natural Resources.</a:t>
                       </a:r>
                       <a:endParaRPr lang="en-US" sz="1600" dirty="0">
                         <a:latin typeface="Calibri" charset="0"/>
@@ -19438,7 +20854,7 @@
             <a:pPr algn="ctr"/>
             <a:fld id="{F7021451-1387-4CA6-816F-3879F97B5CBC}" type="slidenum">
               <a:rPr b="1" lang="en-US"/>
-              <a:t>49</a:t>
+              <a:t>52</a:t>
             </a:fld>
             <a:endParaRPr lang="en-US"/>
           </a:p>
@@ -19452,9 +20868,9 @@
 </p:sld>
 </file>
 
-<file path=ppt/slides/slide5.xml><?xml version="1.0" encoding="utf-8"?>
+<file path=ppt/slides/slide53.xml><?xml version="1.0" encoding="utf-8"?>
 <p:sld xmlns:a="http://schemas.openxmlformats.org/drawingml/2006/main" xmlns:r="http://schemas.openxmlformats.org/officeDocument/2006/relationships" xmlns:p="http://schemas.openxmlformats.org/presentationml/2006/main">
-  <p:cSld name="Slide 5">
+  <p:cSld name="Slide 53">
     <p:spTree>
       <p:nvGrpSpPr>
         <p:cNvPr id="1" name=""/>
@@ -19502,7 +20918,7 @@
                 <a:ea typeface="Calibri" pitchFamily="34" charset="-122"/>
                 <a:cs typeface="Calibri" pitchFamily="34" charset="-120"/>
               </a:rPr>
-              <a:t>OBJECTIVES</a:t>
+              <a:t>TEACHER'S NOTE</a:t>
             </a:r>
             <a:endParaRPr lang="en-US" sz="1400" dirty="0"/>
           </a:p>
@@ -19525,7 +20941,7 @@
         <p:spPr>
           <a:xfrm>
             <a:off x="0" y="658368"/>
-            <a:ext cx="5120640" cy="5833872"/>
+            <a:ext cx="3840480" cy="5833872"/>
           </a:xfrm>
           <a:prstGeom prst="rect">
             <a:avLst/>
@@ -19540,8 +20956,8 @@
         </p:nvSpPr>
         <p:spPr>
           <a:xfrm>
-            <a:off x="5349240" y="1005840"/>
-            <a:ext cx="6522415" cy="731520"/>
+            <a:off x="4069080" y="1005840"/>
+            <a:ext cx="7802575" cy="731520"/>
           </a:xfrm>
           <a:prstGeom prst="rect">
             <a:avLst/>
@@ -19567,7 +20983,7 @@
                 <a:ea typeface="Times New Roman" pitchFamily="34" charset="-122"/>
                 <a:cs typeface="Times New Roman" pitchFamily="34" charset="-120"/>
               </a:rPr>
-              <a:t>Objectives</a:t>
+              <a:t>Teacher's Note</a:t>
             </a:r>
             <a:endParaRPr lang="en-US" sz="3600" dirty="0"/>
           </a:p>
@@ -19581,8 +20997,8 @@
         </p:nvSpPr>
         <p:spPr>
           <a:xfrm>
-            <a:off x="5349240" y="1783080"/>
-            <a:ext cx="6522415" cy="4663440"/>
+            <a:off x="4069080" y="1783080"/>
+            <a:ext cx="7802575" cy="4663440"/>
           </a:xfrm>
           <a:prstGeom prst="rect">
             <a:avLst/>
@@ -19593,47 +21009,26 @@
         <p:txBody>
           <a:bodyPr wrap="square" lIns="0" tIns="0" rIns="0" bIns="0" rtlCol="0" anchor="t"/>
           <a:lstStyle/>
-          <a:p>
-            <a:pPr algn="l" indent="0" marL="0">
-              <a:spcAft>
-                <a:spcPts val="800"/>
-              </a:spcAft>
-              <a:buNone/>
-            </a:pPr>
-            <a:r>
-              <a:rPr lang="en-US" sz="4000" b="1" dirty="0">
-                <a:solidFill>
-                  <a:srgbClr val="111111"/>
-                </a:solidFill>
-                <a:latin typeface="Times New Roman" pitchFamily="34" charset="0"/>
-                <a:ea typeface="Times New Roman" pitchFamily="34" charset="-122"/>
-                <a:cs typeface="Times New Roman" pitchFamily="34" charset="-120"/>
-              </a:rPr>
-              <a:t>By the end of this lesson, you should be able to:</a:t>
-            </a:r>
-            <a:endParaRPr lang="en-US" sz="4000" dirty="0"/>
-          </a:p>
           <a:p>
             <a:pPr algn="l" marL="342900" indent="-342900">
               <a:spcAft>
                 <a:spcPts val="800"/>
               </a:spcAft>
               <a:buSzPct val="100000"/>
-              <a:buFont typeface="+mj-lt"/>
-              <a:buAutoNum type="arabicPeriod" startAt="1"/>
+              <a:buChar char="•"/>
             </a:pPr>
             <a:r>
-              <a:rPr lang="en-US" sz="4000" dirty="0">
+              <a:rPr lang="en-US" sz="2000" dirty="0">
                 <a:solidFill>
                   <a:srgbClr val="111111"/>
                 </a:solidFill>
-                <a:latin typeface="Times New Roman" pitchFamily="34" charset="0"/>
-                <a:ea typeface="Times New Roman" pitchFamily="34" charset="-122"/>
-                <a:cs typeface="Times New Roman" pitchFamily="34" charset="-120"/>
+                <a:latin typeface="Calibri" pitchFamily="34" charset="0"/>
+                <a:ea typeface="Calibri" pitchFamily="34" charset="-122"/>
+                <a:cs typeface="Calibri" pitchFamily="34" charset="-120"/>
               </a:rPr>
-              <a:t>Describe the evolution of the world's population.</a:t>
-            </a:r>
-            <a:endParaRPr lang="en-US" sz="4000" dirty="0"/>
+              <a:t>Timing: Homework correction, plan, objectives 8 min | Recall, situation, action 10 min | 5 activities 30 min | Board summary (copying) 30 min | Evaluation, remediation 10 min | Homework, next lesson 5 min | Logbook 7 min</a:t>
+            </a:r>
+            <a:endParaRPr lang="en-US" sz="2000" dirty="0"/>
           </a:p>
           <a:p>
             <a:pPr algn="l" marL="342900" indent="-342900">
@@ -19641,21 +21036,104 @@
                 <a:spcPts val="800"/>
               </a:spcAft>
               <a:buSzPct val="100000"/>
-              <a:buFont typeface="+mj-lt"/>
-              <a:buAutoNum type="arabicPeriod" startAt="1"/>
+              <a:buChar char="•"/>
             </a:pPr>
             <a:r>
-              <a:rPr lang="en-US" sz="4000" dirty="0">
+              <a:rPr lang="en-US" sz="2000" dirty="0">
                 <a:solidFill>
                   <a:srgbClr val="111111"/>
                 </a:solidFill>
-                <a:latin typeface="Times New Roman" pitchFamily="34" charset="0"/>
-                <a:ea typeface="Times New Roman" pitchFamily="34" charset="-122"/>
-                <a:cs typeface="Times New Roman" pitchFamily="34" charset="-120"/>
+                <a:latin typeface="Calibri" pitchFamily="34" charset="0"/>
+                <a:ea typeface="Calibri" pitchFamily="34" charset="-122"/>
+                <a:cs typeface="Calibri" pitchFamily="34" charset="-120"/>
               </a:rPr>
-              <a:t>Explain the factors of population growth.</a:t>
-            </a:r>
-            <a:endParaRPr lang="en-US" sz="4000" dirty="0"/>
+              <a:t>Without the projector (Activity 1): write the numbers on the board.</a:t>
+            </a:r>
+            <a:endParaRPr lang="en-US" sz="2000" dirty="0"/>
+          </a:p>
+          <a:p>
+            <a:pPr algn="l" marL="342900" indent="-342900">
+              <a:spcAft>
+                <a:spcPts val="800"/>
+              </a:spcAft>
+              <a:buSzPct val="100000"/>
+              <a:buChar char="•"/>
+            </a:pPr>
+            <a:r>
+              <a:rPr lang="en-US" sz="2000" dirty="0">
+                <a:solidFill>
+                  <a:srgbClr val="111111"/>
+                </a:solidFill>
+                <a:latin typeface="Calibri" pitchFamily="34" charset="0"/>
+                <a:ea typeface="Calibri" pitchFamily="34" charset="-122"/>
+                <a:cs typeface="Calibri" pitchFamily="34" charset="-120"/>
+              </a:rPr>
+              <a:t>Without the projector (Activity 2): draw a rising curve.</a:t>
+            </a:r>
+            <a:endParaRPr lang="en-US" sz="2000" dirty="0"/>
+          </a:p>
+          <a:p>
+            <a:pPr algn="l" marL="342900" indent="-342900">
+              <a:spcAft>
+                <a:spcPts val="800"/>
+              </a:spcAft>
+              <a:buSzPct val="100000"/>
+              <a:buChar char="•"/>
+            </a:pPr>
+            <a:r>
+              <a:rPr lang="en-US" sz="2000" dirty="0">
+                <a:solidFill>
+                  <a:srgbClr val="111111"/>
+                </a:solidFill>
+                <a:latin typeface="Calibri" pitchFamily="34" charset="0"/>
+                <a:ea typeface="Calibri" pitchFamily="34" charset="-122"/>
+                <a:cs typeface="Calibri" pitchFamily="34" charset="-120"/>
+              </a:rPr>
+              <a:t>Without the projector (Activity 3): ask about vaccination campaigns.</a:t>
+            </a:r>
+            <a:endParaRPr lang="en-US" sz="2000" dirty="0"/>
+          </a:p>
+          <a:p>
+            <a:pPr algn="l" marL="342900" indent="-342900">
+              <a:spcAft>
+                <a:spcPts val="800"/>
+              </a:spcAft>
+              <a:buSzPct val="100000"/>
+              <a:buChar char="•"/>
+            </a:pPr>
+            <a:r>
+              <a:rPr lang="en-US" sz="2000" dirty="0">
+                <a:solidFill>
+                  <a:srgbClr val="111111"/>
+                </a:solidFill>
+                <a:latin typeface="Calibri" pitchFamily="34" charset="0"/>
+                <a:ea typeface="Calibri" pitchFamily="34" charset="-122"/>
+                <a:cs typeface="Calibri" pitchFamily="34" charset="-120"/>
+              </a:rPr>
+              <a:t>Without the projector (Activity 4): draw two lines.</a:t>
+            </a:r>
+            <a:endParaRPr lang="en-US" sz="2000" dirty="0"/>
+          </a:p>
+          <a:p>
+            <a:pPr algn="l" marL="342900" indent="-342900">
+              <a:spcAft>
+                <a:spcPts val="800"/>
+              </a:spcAft>
+              <a:buSzPct val="100000"/>
+              <a:buChar char="•"/>
+            </a:pPr>
+            <a:r>
+              <a:rPr lang="en-US" sz="2000" dirty="0">
+                <a:solidFill>
+                  <a:srgbClr val="111111"/>
+                </a:solidFill>
+                <a:latin typeface="Calibri" pitchFamily="34" charset="0"/>
+                <a:ea typeface="Calibri" pitchFamily="34" charset="-122"/>
+                <a:cs typeface="Calibri" pitchFamily="34" charset="-120"/>
+              </a:rPr>
+              <a:t>Without the projector (Activity 5): discuss the village of the situation.</a:t>
+            </a:r>
+            <a:endParaRPr lang="en-US" sz="2000" dirty="0"/>
           </a:p>
         </p:txBody>
       </p:sp>
@@ -19701,7 +21179,7 @@
             <a:pPr algn="ctr"/>
             <a:fld id="{F7021451-1387-4CA6-816F-3879F97B5CBC}" type="slidenum">
               <a:rPr b="1" lang="en-US"/>
-              <a:t>5</a:t>
+              <a:t>53</a:t>
             </a:fld>
             <a:endParaRPr lang="en-US"/>
           </a:p>
@@ -19715,9 +21193,9 @@
 </p:sld>
 </file>
 
-<file path=ppt/slides/slide50.xml><?xml version="1.0" encoding="utf-8"?>
+<file path=ppt/slides/slide54.xml><?xml version="1.0" encoding="utf-8"?>
 <p:sld xmlns:a="http://schemas.openxmlformats.org/drawingml/2006/main" xmlns:r="http://schemas.openxmlformats.org/officeDocument/2006/relationships" xmlns:p="http://schemas.openxmlformats.org/presentationml/2006/main">
-  <p:cSld name="Slide 50">
+  <p:cSld name="Slide 54">
     <p:spTree>
       <p:nvGrpSpPr>
         <p:cNvPr id="1" name=""/>
@@ -19765,7 +21243,7 @@
                 <a:ea typeface="Calibri" pitchFamily="34" charset="-122"/>
                 <a:cs typeface="Calibri" pitchFamily="34" charset="-120"/>
               </a:rPr>
-              <a:t>TEACHER'S NOTE</a:t>
+              <a:t>REFERENCES</a:t>
             </a:r>
             <a:endParaRPr lang="en-US" sz="1400" dirty="0"/>
           </a:p>
@@ -19788,7 +21266,7 @@
         <p:spPr>
           <a:xfrm>
             <a:off x="0" y="658368"/>
-            <a:ext cx="3840480" cy="5833872"/>
+            <a:ext cx="5120640" cy="5833872"/>
           </a:xfrm>
           <a:prstGeom prst="rect">
             <a:avLst/>
@@ -19803,8 +21281,8 @@
         </p:nvSpPr>
         <p:spPr>
           <a:xfrm>
-            <a:off x="4069080" y="1005840"/>
-            <a:ext cx="7802575" cy="731520"/>
+            <a:off x="5349240" y="1005840"/>
+            <a:ext cx="6522415" cy="731520"/>
           </a:xfrm>
           <a:prstGeom prst="rect">
             <a:avLst/>
@@ -19830,7 +21308,7 @@
                 <a:ea typeface="Times New Roman" pitchFamily="34" charset="-122"/>
                 <a:cs typeface="Times New Roman" pitchFamily="34" charset="-120"/>
               </a:rPr>
-              <a:t>Teacher's Note</a:t>
+              <a:t>References</a:t>
             </a:r>
             <a:endParaRPr lang="en-US" sz="3600" dirty="0"/>
           </a:p>
@@ -19844,8 +21322,8 @@
         </p:nvSpPr>
         <p:spPr>
           <a:xfrm>
-            <a:off x="4069080" y="1783080"/>
-            <a:ext cx="7802575" cy="4663440"/>
+            <a:off x="5349240" y="1783080"/>
+            <a:ext cx="6522415" cy="4663440"/>
           </a:xfrm>
           <a:prstGeom prst="rect">
             <a:avLst/>
@@ -19865,7 +21343,7 @@
               <a:buChar char="•"/>
             </a:pPr>
             <a:r>
-              <a:rPr lang="en-US" sz="2000" dirty="0">
+              <a:rPr lang="en-US" sz="1800" dirty="0">
                 <a:solidFill>
                   <a:srgbClr val="111111"/>
                 </a:solidFill>
@@ -19873,9 +21351,9 @@
                 <a:ea typeface="Calibri" pitchFamily="34" charset="-122"/>
                 <a:cs typeface="Calibri" pitchFamily="34" charset="-120"/>
               </a:rPr>
-              <a:t>Timing: Homework correction, plan, objectives 8 min | Recall, situation, action 10 min | 5 activities 30 min | Board summary (copying) 30 min | Evaluation, remediation 10 min | Homework, next lesson 5 min | Logbook 7 min</a:t>
-            </a:r>
-            <a:endParaRPr lang="en-US" sz="2000" dirty="0"/>
+              <a:t>Geography Syllabus, Forms I–V, MINESEC (2023) — Form 2, Module 1: Man in his Environment.</a:t>
+            </a:r>
+            <a:endParaRPr lang="en-US" sz="1800" dirty="0"/>
           </a:p>
           <a:p>
             <a:pPr algn="l" marL="342900" indent="-342900">
@@ -19886,7 +21364,7 @@
               <a:buChar char="•"/>
             </a:pPr>
             <a:r>
-              <a:rPr lang="en-US" sz="2000" dirty="0">
+              <a:rPr lang="en-US" sz="1800" dirty="0">
                 <a:solidFill>
                   <a:srgbClr val="111111"/>
                 </a:solidFill>
@@ -19894,9 +21372,9 @@
                 <a:ea typeface="Calibri" pitchFamily="34" charset="-122"/>
                 <a:cs typeface="Calibri" pitchFamily="34" charset="-120"/>
               </a:rPr>
-              <a:t>Without the projector (Activity 1): write the numbers on the board.</a:t>
-            </a:r>
-            <a:endParaRPr lang="en-US" sz="2000" dirty="0"/>
+              <a:t>Photo, Activity 3: “Isatu gets a vaccination for her 5 week old son” by World Bank Photo Collection, CC BY-NC-ND 2.0, via Flickr (https://www.flickr.com/photos/10816734@N03/26372818523)</a:t>
+            </a:r>
+            <a:endParaRPr lang="en-US" sz="1800" dirty="0"/>
           </a:p>
           <a:p>
             <a:pPr algn="l" marL="342900" indent="-342900">
@@ -19907,7 +21385,7 @@
               <a:buChar char="•"/>
             </a:pPr>
             <a:r>
-              <a:rPr lang="en-US" sz="2000" dirty="0">
+              <a:rPr lang="en-US" sz="1800" dirty="0">
                 <a:solidFill>
                   <a:srgbClr val="111111"/>
                 </a:solidFill>
@@ -19915,9 +21393,9 @@
                 <a:ea typeface="Calibri" pitchFamily="34" charset="-122"/>
                 <a:cs typeface="Calibri" pitchFamily="34" charset="-120"/>
               </a:rPr>
-              <a:t>Without the projector (Activity 2): describe a crowded place.</a:t>
-            </a:r>
-            <a:endParaRPr lang="en-US" sz="2000" dirty="0"/>
+              <a:t>Photo, Activity 5: “Slash and burn agriculture in the Amazon” by Matt-Zimmerman, CC BY 2.0, via Flickr (https://www.flickr.com/photos/16725630@N00/1524189000)</a:t>
+            </a:r>
+            <a:endParaRPr lang="en-US" sz="1800" dirty="0"/>
           </a:p>
           <a:p>
             <a:pPr algn="l" marL="342900" indent="-342900">
@@ -19928,7 +21406,7 @@
               <a:buChar char="•"/>
             </a:pPr>
             <a:r>
-              <a:rPr lang="en-US" sz="2000" dirty="0">
+              <a:rPr lang="en-US" sz="1800" dirty="0">
                 <a:solidFill>
                   <a:srgbClr val="111111"/>
                 </a:solidFill>
@@ -19936,9 +21414,9 @@
                 <a:ea typeface="Calibri" pitchFamily="34" charset="-122"/>
                 <a:cs typeface="Calibri" pitchFamily="34" charset="-120"/>
               </a:rPr>
-              <a:t>Without the projector (Activity 3): ask about vaccination campaigns.</a:t>
-            </a:r>
-            <a:endParaRPr lang="en-US" sz="2000" dirty="0"/>
+              <a:t>Photo, board summary (High birth rate): “African school children” by World Resources, CC BY-NC-SA 2.0, via Flickr (https://www.flickr.com/photos/26107309@N05/2658469563)</a:t>
+            </a:r>
+            <a:endParaRPr lang="en-US" sz="1800" dirty="0"/>
           </a:p>
           <a:p>
             <a:pPr algn="l" marL="342900" indent="-342900">
@@ -19949,7 +21427,7 @@
               <a:buChar char="•"/>
             </a:pPr>
             <a:r>
-              <a:rPr lang="en-US" sz="2000" dirty="0">
+              <a:rPr lang="en-US" sz="1800" dirty="0">
                 <a:solidFill>
                   <a:srgbClr val="111111"/>
                 </a:solidFill>
@@ -19957,30 +21435,9 @@
                 <a:ea typeface="Calibri" pitchFamily="34" charset="-122"/>
                 <a:cs typeface="Calibri" pitchFamily="34" charset="-120"/>
               </a:rPr>
-              <a:t>Without the projector (Activity 4): draw two lines.</a:t>
-            </a:r>
-            <a:endParaRPr lang="en-US" sz="2000" dirty="0"/>
-          </a:p>
-          <a:p>
-            <a:pPr algn="l" marL="342900" indent="-342900">
-              <a:spcAft>
-                <a:spcPts val="800"/>
-              </a:spcAft>
-              <a:buSzPct val="100000"/>
-              <a:buChar char="•"/>
-            </a:pPr>
-            <a:r>
-              <a:rPr lang="en-US" sz="2000" dirty="0">
-                <a:solidFill>
-                  <a:srgbClr val="111111"/>
-                </a:solidFill>
-                <a:latin typeface="Calibri" pitchFamily="34" charset="0"/>
-                <a:ea typeface="Calibri" pitchFamily="34" charset="-122"/>
-                <a:cs typeface="Calibri" pitchFamily="34" charset="-120"/>
-              </a:rPr>
-              <a:t>Without the projector (Activity 5): discuss the village of the situation.</a:t>
-            </a:r>
-            <a:endParaRPr lang="en-US" sz="2000" dirty="0"/>
+              <a:t>Diagrams and animations: drawn for this lesson (Geography Department).</a:t>
+            </a:r>
+            <a:endParaRPr lang="en-US" sz="1800" dirty="0"/>
           </a:p>
         </p:txBody>
       </p:sp>
@@ -20026,311 +21483,7 @@
             <a:pPr algn="ctr"/>
             <a:fld id="{F7021451-1387-4CA6-816F-3879F97B5CBC}" type="slidenum">
               <a:rPr b="1" lang="en-US"/>
-              <a:t>50</a:t>
-            </a:fld>
-            <a:endParaRPr lang="en-US"/>
-          </a:p>
-        </p:txBody>
-      </p:sp>
-    </p:spTree>
-  </p:cSld>
-  <p:clrMapOvr>
-    <a:masterClrMapping/>
-  </p:clrMapOvr>
-</p:sld>
-</file>
-
-<file path=ppt/slides/slide51.xml><?xml version="1.0" encoding="utf-8"?>
-<p:sld xmlns:a="http://schemas.openxmlformats.org/drawingml/2006/main" xmlns:r="http://schemas.openxmlformats.org/officeDocument/2006/relationships" xmlns:p="http://schemas.openxmlformats.org/presentationml/2006/main">
-  <p:cSld name="Slide 51">
-    <p:spTree>
-      <p:nvGrpSpPr>
-        <p:cNvPr id="1" name=""/>
-        <p:cNvGrpSpPr/>
-        <p:nvPr/>
-      </p:nvGrpSpPr>
-      <p:grpSpPr>
-        <a:xfrm>
-          <a:off x="0" y="0"/>
-          <a:ext cx="0" cy="0"/>
-          <a:chOff x="0" y="0"/>
-          <a:chExt cx="0" cy="0"/>
-        </a:xfrm>
-      </p:grpSpPr>
-      <p:sp>
-        <p:nvSpPr>
-          <p:cNvPr id="2" name="Text 0"/>
-          <p:cNvSpPr/>
-          <p:nvPr/>
-        </p:nvSpPr>
-        <p:spPr>
-          <a:xfrm>
-            <a:off x="457200" y="713232"/>
-            <a:ext cx="11368735" cy="274320"/>
-          </a:xfrm>
-          <a:prstGeom prst="rect">
-            <a:avLst/>
-          </a:prstGeom>
-          <a:noFill/>
-          <a:ln/>
-        </p:spPr>
-        <p:txBody>
-          <a:bodyPr wrap="square" lIns="0" tIns="0" rIns="0" bIns="0" rtlCol="0" anchor="ctr"/>
-          <a:lstStyle/>
-          <a:p>
-            <a:pPr algn="r" indent="0" marL="0">
-              <a:buNone/>
-            </a:pPr>
-            <a:r>
-              <a:rPr lang="en-US" sz="1400" b="1" dirty="0">
-                <a:solidFill>
-                  <a:srgbClr val="1C3F6E"/>
-                </a:solidFill>
-                <a:latin typeface="Calibri" pitchFamily="34" charset="0"/>
-                <a:ea typeface="Calibri" pitchFamily="34" charset="-122"/>
-                <a:cs typeface="Calibri" pitchFamily="34" charset="-120"/>
-              </a:rPr>
-              <a:t>REFERENCES</a:t>
-            </a:r>
-            <a:endParaRPr lang="en-US" sz="1400" dirty="0"/>
-          </a:p>
-        </p:txBody>
-      </p:sp>
-      <p:pic>
-        <p:nvPicPr>
-          <p:cNvPr id="3" name="Image 0" descr="/home/claude/f4/img/minesec_sheet.png">    </p:cNvPr>
-          <p:cNvPicPr>
-            <a:picLocks noChangeAspect="1"/>
-          </p:cNvPicPr>
-          <p:nvPr/>
-        </p:nvPicPr>
-        <p:blipFill>
-          <a:blip r:embed="rId1"/>
-          <a:stretch>
-            <a:fillRect/>
-          </a:stretch>
-        </p:blipFill>
-        <p:spPr>
-          <a:xfrm>
-            <a:off x="0" y="658368"/>
-            <a:ext cx="5120640" cy="5833872"/>
-          </a:xfrm>
-          <a:prstGeom prst="rect">
-            <a:avLst/>
-          </a:prstGeom>
-        </p:spPr>
-      </p:pic>
-      <p:sp>
-        <p:nvSpPr>
-          <p:cNvPr id="4" name="Text 1"/>
-          <p:cNvSpPr/>
-          <p:nvPr/>
-        </p:nvSpPr>
-        <p:spPr>
-          <a:xfrm>
-            <a:off x="5349240" y="1005840"/>
-            <a:ext cx="6522415" cy="731520"/>
-          </a:xfrm>
-          <a:prstGeom prst="rect">
-            <a:avLst/>
-          </a:prstGeom>
-          <a:noFill/>
-          <a:ln/>
-        </p:spPr>
-        <p:txBody>
-          <a:bodyPr wrap="square" lIns="0" tIns="0" rIns="0" bIns="0" rtlCol="0" anchor="ctr">
-            <a:normAutofit/>
-          </a:bodyPr>
-          <a:lstStyle/>
-          <a:p>
-            <a:pPr algn="ctr" indent="0" marL="0">
-              <a:buNone/>
-            </a:pPr>
-            <a:r>
-              <a:rPr lang="en-US" sz="3600" b="1" dirty="0">
-                <a:solidFill>
-                  <a:srgbClr val="990011"/>
-                </a:solidFill>
-                <a:latin typeface="Times New Roman" pitchFamily="34" charset="0"/>
-                <a:ea typeface="Times New Roman" pitchFamily="34" charset="-122"/>
-                <a:cs typeface="Times New Roman" pitchFamily="34" charset="-120"/>
-              </a:rPr>
-              <a:t>References</a:t>
-            </a:r>
-            <a:endParaRPr lang="en-US" sz="3600" dirty="0"/>
-          </a:p>
-        </p:txBody>
-      </p:sp>
-      <p:sp>
-        <p:nvSpPr>
-          <p:cNvPr id="5" name="Text 2"/>
-          <p:cNvSpPr/>
-          <p:nvPr/>
-        </p:nvSpPr>
-        <p:spPr>
-          <a:xfrm>
-            <a:off x="5349240" y="1783080"/>
-            <a:ext cx="6522415" cy="4663440"/>
-          </a:xfrm>
-          <a:prstGeom prst="rect">
-            <a:avLst/>
-          </a:prstGeom>
-          <a:noFill/>
-          <a:ln/>
-        </p:spPr>
-        <p:txBody>
-          <a:bodyPr wrap="square" lIns="0" tIns="0" rIns="0" bIns="0" rtlCol="0" anchor="t"/>
-          <a:lstStyle/>
-          <a:p>
-            <a:pPr algn="l" marL="342900" indent="-342900">
-              <a:spcAft>
-                <a:spcPts val="800"/>
-              </a:spcAft>
-              <a:buSzPct val="100000"/>
-              <a:buChar char="•"/>
-            </a:pPr>
-            <a:r>
-              <a:rPr lang="en-US" sz="1800" dirty="0">
-                <a:solidFill>
-                  <a:srgbClr val="111111"/>
-                </a:solidFill>
-                <a:latin typeface="Calibri" pitchFamily="34" charset="0"/>
-                <a:ea typeface="Calibri" pitchFamily="34" charset="-122"/>
-                <a:cs typeface="Calibri" pitchFamily="34" charset="-120"/>
-              </a:rPr>
-              <a:t>Geography Syllabus, Forms I–V, MINESEC (2023) — Form 2, Module 1: Man in his Environment.</a:t>
-            </a:r>
-            <a:endParaRPr lang="en-US" sz="1800" dirty="0"/>
-          </a:p>
-          <a:p>
-            <a:pPr algn="l" marL="342900" indent="-342900">
-              <a:spcAft>
-                <a:spcPts val="800"/>
-              </a:spcAft>
-              <a:buSzPct val="100000"/>
-              <a:buChar char="•"/>
-            </a:pPr>
-            <a:r>
-              <a:rPr lang="en-US" sz="1800" dirty="0">
-                <a:solidFill>
-                  <a:srgbClr val="111111"/>
-                </a:solidFill>
-                <a:latin typeface="Calibri" pitchFamily="34" charset="0"/>
-                <a:ea typeface="Calibri" pitchFamily="34" charset="-122"/>
-                <a:cs typeface="Calibri" pitchFamily="34" charset="-120"/>
-              </a:rPr>
-              <a:t>Photo, Activity 2: “Wax market” by zouzouwizman, CC BY 2.0, via Flickr (https://www.flickr.com/photos/61111202@N00/12129001)</a:t>
-            </a:r>
-            <a:endParaRPr lang="en-US" sz="1800" dirty="0"/>
-          </a:p>
-          <a:p>
-            <a:pPr algn="l" marL="342900" indent="-342900">
-              <a:spcAft>
-                <a:spcPts val="800"/>
-              </a:spcAft>
-              <a:buSzPct val="100000"/>
-              <a:buChar char="•"/>
-            </a:pPr>
-            <a:r>
-              <a:rPr lang="en-US" sz="1800" dirty="0">
-                <a:solidFill>
-                  <a:srgbClr val="111111"/>
-                </a:solidFill>
-                <a:latin typeface="Calibri" pitchFamily="34" charset="0"/>
-                <a:ea typeface="Calibri" pitchFamily="34" charset="-122"/>
-                <a:cs typeface="Calibri" pitchFamily="34" charset="-120"/>
-              </a:rPr>
-              <a:t>Photo, Activity 3: “Isatu gets a vaccination for her 5 week old son” by World Bank Photo Collection, CC BY-NC-ND 2.0, via Flickr (https://www.flickr.com/photos/10816734@N03/26372818523)</a:t>
-            </a:r>
-            <a:endParaRPr lang="en-US" sz="1800" dirty="0"/>
-          </a:p>
-          <a:p>
-            <a:pPr algn="l" marL="342900" indent="-342900">
-              <a:spcAft>
-                <a:spcPts val="800"/>
-              </a:spcAft>
-              <a:buSzPct val="100000"/>
-              <a:buChar char="•"/>
-            </a:pPr>
-            <a:r>
-              <a:rPr lang="en-US" sz="1800" dirty="0">
-                <a:solidFill>
-                  <a:srgbClr val="111111"/>
-                </a:solidFill>
-                <a:latin typeface="Calibri" pitchFamily="34" charset="0"/>
-                <a:ea typeface="Calibri" pitchFamily="34" charset="-122"/>
-                <a:cs typeface="Calibri" pitchFamily="34" charset="-120"/>
-              </a:rPr>
-              <a:t>Photo, Activity 5: “Slash and burn agriculture in the Amazon” by Matt-Zimmerman, CC BY 2.0, via Flickr (https://www.flickr.com/photos/16725630@N00/1524189000)</a:t>
-            </a:r>
-            <a:endParaRPr lang="en-US" sz="1800" dirty="0"/>
-          </a:p>
-          <a:p>
-            <a:pPr algn="l" marL="342900" indent="-342900">
-              <a:spcAft>
-                <a:spcPts val="800"/>
-              </a:spcAft>
-              <a:buSzPct val="100000"/>
-              <a:buChar char="•"/>
-            </a:pPr>
-            <a:r>
-              <a:rPr lang="en-US" sz="1800" dirty="0">
-                <a:solidFill>
-                  <a:srgbClr val="111111"/>
-                </a:solidFill>
-                <a:latin typeface="Calibri" pitchFamily="34" charset="0"/>
-                <a:ea typeface="Calibri" pitchFamily="34" charset="-122"/>
-                <a:cs typeface="Calibri" pitchFamily="34" charset="-120"/>
-              </a:rPr>
-              <a:t>Diagrams and animations: drawn for this lesson (Geography Department).</a:t>
-            </a:r>
-            <a:endParaRPr lang="en-US" sz="1800" dirty="0"/>
-          </a:p>
-        </p:txBody>
-      </p:sp>
-      <p:sp>
-        <p:nvSpPr>
-          <p:cNvPr id="25" name="Slide Number Placeholder 0"/>
-          <p:cNvSpPr>
-            <a:spLocks noGrp="1"/>
-          </p:cNvSpPr>
-          <p:nvPr>
-            <p:ph type="sldNum" sz="quarter" idx="4294967295"/>
-          </p:nvPr>
-        </p:nvSpPr>
-        <p:spPr>
-          <a:xfrm>
-            <a:off x="27432" y="91440"/>
-            <a:ext cx="585216" cy="475488"/>
-          </a:xfrm>
-          <a:prstGeom prst="rect">
-            <a:avLst/>
-          </a:prstGeom>
-          <a:extLst>
-            <a:ext uri="{C572A759-6A51-4108-AA02-DFA0A04FC94B}">
-              <ma14:wrappingTextBoxFlag xmlns:ma14="http://schemas.microsoft.com/office/mac/drawingml/2011/main" val="0"/>
-            </a:ext>
-          </a:extLst>
-        </p:spPr>
-        <p:txBody>
-          <a:bodyPr/>
-          <a:lstStyle>
-            <a:lvl1pPr>
-              <a:defRPr sz="2000">
-                <a:solidFill>
-                  <a:srgbClr val="FFFFFF"/>
-                </a:solidFill>
-                <a:latin typeface="Calibri"/>
-                <a:ea typeface="Calibri"/>
-                <a:cs typeface="Calibri"/>
-              </a:defRPr>
-            </a:lvl1pPr>
-          </a:lstStyle>
-          <a:p>
-            <a:pPr algn="ctr"/>
-            <a:fld id="{F7021451-1387-4CA6-816F-3879F97B5CBC}" type="slidenum">
-              <a:rPr b="1" lang="en-US"/>
-              <a:t>51</a:t>
+              <a:t>54</a:t>
             </a:fld>
             <a:endParaRPr lang="en-US"/>
           </a:p>
@@ -20900,7 +22053,7 @@
         <p:spPr>
           <a:xfrm>
             <a:off x="0" y="658368"/>
-            <a:ext cx="3840480" cy="5833872"/>
+            <a:ext cx="1463040" cy="5833872"/>
           </a:xfrm>
           <a:prstGeom prst="rect">
             <a:avLst/>
@@ -20915,8 +22068,8 @@
         </p:nvSpPr>
         <p:spPr>
           <a:xfrm>
-            <a:off x="4069080" y="1005840"/>
-            <a:ext cx="7802575" cy="731520"/>
+            <a:off x="1691640" y="1005840"/>
+            <a:ext cx="10180015" cy="731520"/>
           </a:xfrm>
           <a:prstGeom prst="rect">
             <a:avLst/>
@@ -20956,8 +22109,8 @@
         </p:nvSpPr>
         <p:spPr>
           <a:xfrm>
-            <a:off x="4069080" y="1783080"/>
-            <a:ext cx="7802575" cy="4663440"/>
+            <a:off x="1691640" y="1783080"/>
+            <a:ext cx="10180015" cy="4663440"/>
           </a:xfrm>
           <a:prstGeom prst="rect">
             <a:avLst/>
@@ -20984,7 +22137,7 @@
                 <a:ea typeface="Times New Roman" pitchFamily="34" charset="-122"/>
                 <a:cs typeface="Times New Roman" pitchFamily="34" charset="-120"/>
               </a:rPr>
-              <a:t>Grandmother Hawa says that when she was young, her village had only a few compounds and plenty of land. Today the village is crowded, the forest has disappeared and farms are small.</a:t>
+              <a:t>Grandmother Hawa says that when she was young, her village had only a few compounds and plenty of land. Today the village is crowded, the forest has disappeared and the farms are small. Her grandson asks: "Why are there so many more people today, and what will happen to our land?"</a:t>
             </a:r>
             <a:endParaRPr lang="en-US" sz="4000" dirty="0"/>
           </a:p>

</xml_diff>